<commit_message>
[FHIR-56895](https://jira.hl7.org/browse/FHIR-56895): Added payer/provider reporting scenario to illustrate overall interactions
</commit_message>
<xml_diff>
--- a/input/images/source/DEQM IG Diagram.pptx
+++ b/input/images/source/DEQM IG Diagram.pptx
@@ -5,7 +5,7 @@
     <p:sldMasterId id="2147483648" r:id="rId1"/>
   </p:sldMasterIdLst>
   <p:notesMasterIdLst>
-    <p:notesMasterId r:id="rId13"/>
+    <p:notesMasterId r:id="rId15"/>
   </p:notesMasterIdLst>
   <p:sldIdLst>
     <p:sldId id="261" r:id="rId2"/>
@@ -19,6 +19,8 @@
     <p:sldId id="262" r:id="rId10"/>
     <p:sldId id="258" r:id="rId11"/>
     <p:sldId id="4866" r:id="rId12"/>
+    <p:sldId id="4890" r:id="rId13"/>
+    <p:sldId id="4891" r:id="rId14"/>
   </p:sldIdLst>
   <p:sldSz cx="12192000" cy="6858000"/>
   <p:notesSz cx="6858000" cy="9144000"/>
@@ -207,7 +209,7 @@
           <a:p>
             <a:fld id="{8003B671-C942-4B48-A4AA-E54C0E868887}" type="datetimeFigureOut">
               <a:rPr lang="en-US" smtClean="0"/>
-              <a:t>3/15/2026</a:t>
+              <a:t>7/28/2026</a:t>
             </a:fld>
             <a:endParaRPr lang="en-US"/>
           </a:p>
@@ -705,7 +707,7 @@
           <a:p>
             <a:fld id="{A1C33FE8-8021-45D4-B0C5-0B5FC73F013B}" type="datetimeFigureOut">
               <a:rPr lang="en-US" smtClean="0"/>
-              <a:t>3/15/2026</a:t>
+              <a:t>7/28/2026</a:t>
             </a:fld>
             <a:endParaRPr lang="en-US"/>
           </a:p>
@@ -903,7 +905,7 @@
           <a:p>
             <a:fld id="{A1C33FE8-8021-45D4-B0C5-0B5FC73F013B}" type="datetimeFigureOut">
               <a:rPr lang="en-US" smtClean="0"/>
-              <a:t>3/15/2026</a:t>
+              <a:t>7/28/2026</a:t>
             </a:fld>
             <a:endParaRPr lang="en-US"/>
           </a:p>
@@ -1111,7 +1113,7 @@
           <a:p>
             <a:fld id="{A1C33FE8-8021-45D4-B0C5-0B5FC73F013B}" type="datetimeFigureOut">
               <a:rPr lang="en-US" smtClean="0"/>
-              <a:t>3/15/2026</a:t>
+              <a:t>7/28/2026</a:t>
             </a:fld>
             <a:endParaRPr lang="en-US"/>
           </a:p>
@@ -2255,7 +2257,7 @@
           <a:p>
             <a:fld id="{A1C33FE8-8021-45D4-B0C5-0B5FC73F013B}" type="datetimeFigureOut">
               <a:rPr lang="en-US" smtClean="0"/>
-              <a:t>3/15/2026</a:t>
+              <a:t>7/28/2026</a:t>
             </a:fld>
             <a:endParaRPr lang="en-US"/>
           </a:p>
@@ -2530,7 +2532,7 @@
           <a:p>
             <a:fld id="{A1C33FE8-8021-45D4-B0C5-0B5FC73F013B}" type="datetimeFigureOut">
               <a:rPr lang="en-US" smtClean="0"/>
-              <a:t>3/15/2026</a:t>
+              <a:t>7/28/2026</a:t>
             </a:fld>
             <a:endParaRPr lang="en-US"/>
           </a:p>
@@ -2795,7 +2797,7 @@
           <a:p>
             <a:fld id="{A1C33FE8-8021-45D4-B0C5-0B5FC73F013B}" type="datetimeFigureOut">
               <a:rPr lang="en-US" smtClean="0"/>
-              <a:t>3/15/2026</a:t>
+              <a:t>7/28/2026</a:t>
             </a:fld>
             <a:endParaRPr lang="en-US"/>
           </a:p>
@@ -3207,7 +3209,7 @@
           <a:p>
             <a:fld id="{A1C33FE8-8021-45D4-B0C5-0B5FC73F013B}" type="datetimeFigureOut">
               <a:rPr lang="en-US" smtClean="0"/>
-              <a:t>3/15/2026</a:t>
+              <a:t>7/28/2026</a:t>
             </a:fld>
             <a:endParaRPr lang="en-US"/>
           </a:p>
@@ -3348,7 +3350,7 @@
           <a:p>
             <a:fld id="{A1C33FE8-8021-45D4-B0C5-0B5FC73F013B}" type="datetimeFigureOut">
               <a:rPr lang="en-US" smtClean="0"/>
-              <a:t>3/15/2026</a:t>
+              <a:t>7/28/2026</a:t>
             </a:fld>
             <a:endParaRPr lang="en-US"/>
           </a:p>
@@ -3461,7 +3463,7 @@
           <a:p>
             <a:fld id="{A1C33FE8-8021-45D4-B0C5-0B5FC73F013B}" type="datetimeFigureOut">
               <a:rPr lang="en-US" smtClean="0"/>
-              <a:t>3/15/2026</a:t>
+              <a:t>7/28/2026</a:t>
             </a:fld>
             <a:endParaRPr lang="en-US"/>
           </a:p>
@@ -3772,7 +3774,7 @@
           <a:p>
             <a:fld id="{A1C33FE8-8021-45D4-B0C5-0B5FC73F013B}" type="datetimeFigureOut">
               <a:rPr lang="en-US" smtClean="0"/>
-              <a:t>3/15/2026</a:t>
+              <a:t>7/28/2026</a:t>
             </a:fld>
             <a:endParaRPr lang="en-US"/>
           </a:p>
@@ -4060,7 +4062,7 @@
           <a:p>
             <a:fld id="{A1C33FE8-8021-45D4-B0C5-0B5FC73F013B}" type="datetimeFigureOut">
               <a:rPr lang="en-US" smtClean="0"/>
-              <a:t>3/15/2026</a:t>
+              <a:t>7/28/2026</a:t>
             </a:fld>
             <a:endParaRPr lang="en-US"/>
           </a:p>
@@ -4301,7 +4303,7 @@
           <a:p>
             <a:fld id="{A1C33FE8-8021-45D4-B0C5-0B5FC73F013B}" type="datetimeFigureOut">
               <a:rPr lang="en-US" smtClean="0"/>
-              <a:t>3/15/2026</a:t>
+              <a:t>7/28/2026</a:t>
             </a:fld>
             <a:endParaRPr lang="en-US"/>
           </a:p>
@@ -5931,6 +5933,2464 @@
     <p:extLst>
       <p:ext uri="{BB962C8B-B14F-4D97-AF65-F5344CB8AC3E}">
         <p14:creationId xmlns:p14="http://schemas.microsoft.com/office/powerpoint/2010/main" val="818937061"/>
+      </p:ext>
+    </p:extLst>
+  </p:cSld>
+  <p:clrMapOvr>
+    <a:masterClrMapping/>
+  </p:clrMapOvr>
+</p:sld>
+</file>
+
+<file path=ppt/slides/slide12.xml><?xml version="1.0" encoding="utf-8"?>
+<p:sld xmlns:a="http://schemas.openxmlformats.org/drawingml/2006/main" xmlns:r="http://schemas.openxmlformats.org/officeDocument/2006/relationships" xmlns:p="http://schemas.openxmlformats.org/presentationml/2006/main">
+  <p:cSld>
+    <p:spTree>
+      <p:nvGrpSpPr>
+        <p:cNvPr id="1" name="">
+          <a:extLst>
+            <a:ext uri="{FF2B5EF4-FFF2-40B4-BE49-F238E27FC236}">
+              <a16:creationId xmlns:a16="http://schemas.microsoft.com/office/drawing/2014/main" id="{2D8E8987-9423-5E81-D69B-660B6A113056}"/>
+            </a:ext>
+          </a:extLst>
+        </p:cNvPr>
+        <p:cNvGrpSpPr/>
+        <p:nvPr/>
+      </p:nvGrpSpPr>
+      <p:grpSpPr>
+        <a:xfrm>
+          <a:off x="0" y="0"/>
+          <a:ext cx="0" cy="0"/>
+          <a:chOff x="0" y="0"/>
+          <a:chExt cx="0" cy="0"/>
+        </a:xfrm>
+      </p:grpSpPr>
+      <p:sp>
+        <p:nvSpPr>
+          <p:cNvPr id="2" name="Title 1">
+            <a:extLst>
+              <a:ext uri="{FF2B5EF4-FFF2-40B4-BE49-F238E27FC236}">
+                <a16:creationId xmlns:a16="http://schemas.microsoft.com/office/drawing/2014/main" id="{DA70738B-81D1-0AA1-C935-6F94EB429CCE}"/>
+              </a:ext>
+            </a:extLst>
+          </p:cNvPr>
+          <p:cNvSpPr>
+            <a:spLocks noGrp="1"/>
+          </p:cNvSpPr>
+          <p:nvPr>
+            <p:ph type="title"/>
+          </p:nvPr>
+        </p:nvSpPr>
+        <p:spPr/>
+        <p:txBody>
+          <a:bodyPr/>
+          <a:lstStyle/>
+          <a:p>
+            <a:r>
+              <a:rPr lang="en-US" dirty="0"/>
+              <a:t>Payer/Provider Reporting – Setup </a:t>
+            </a:r>
+          </a:p>
+        </p:txBody>
+      </p:sp>
+      <p:sp>
+        <p:nvSpPr>
+          <p:cNvPr id="4" name="Slide Number Placeholder 3">
+            <a:extLst>
+              <a:ext uri="{FF2B5EF4-FFF2-40B4-BE49-F238E27FC236}">
+                <a16:creationId xmlns:a16="http://schemas.microsoft.com/office/drawing/2014/main" id="{88005720-2530-5D98-2911-7D4EE9D9B46E}"/>
+              </a:ext>
+            </a:extLst>
+          </p:cNvPr>
+          <p:cNvSpPr>
+            <a:spLocks noGrp="1"/>
+          </p:cNvSpPr>
+          <p:nvPr>
+            <p:ph type="sldNum" sz="quarter" idx="12"/>
+          </p:nvPr>
+        </p:nvSpPr>
+        <p:spPr/>
+        <p:txBody>
+          <a:bodyPr/>
+          <a:lstStyle/>
+          <a:p>
+            <a:fld id="{00000000-1234-1234-1234-123412341234}" type="slidenum">
+              <a:rPr lang="en-US" smtClean="0"/>
+              <a:pPr/>
+              <a:t>12</a:t>
+            </a:fld>
+            <a:endParaRPr lang="en-US" dirty="0"/>
+          </a:p>
+        </p:txBody>
+      </p:sp>
+      <p:grpSp>
+        <p:nvGrpSpPr>
+          <p:cNvPr id="50" name="Group 49">
+            <a:extLst>
+              <a:ext uri="{FF2B5EF4-FFF2-40B4-BE49-F238E27FC236}">
+                <a16:creationId xmlns:a16="http://schemas.microsoft.com/office/drawing/2014/main" id="{1C19A899-8540-4511-1FF8-99A35D3935A2}"/>
+              </a:ext>
+            </a:extLst>
+          </p:cNvPr>
+          <p:cNvGrpSpPr/>
+          <p:nvPr/>
+        </p:nvGrpSpPr>
+        <p:grpSpPr>
+          <a:xfrm>
+            <a:off x="9895276" y="3878241"/>
+            <a:ext cx="1156925" cy="1027936"/>
+            <a:chOff x="7183635" y="2698018"/>
+            <a:chExt cx="867694" cy="770952"/>
+          </a:xfrm>
+        </p:grpSpPr>
+        <p:pic>
+          <p:nvPicPr>
+            <p:cNvPr id="49" name="Picture 10" descr="Engine Gears Icon SVG Vector &amp; PNG Free Download | UXWing">
+              <a:extLst>
+                <a:ext uri="{FF2B5EF4-FFF2-40B4-BE49-F238E27FC236}">
+                  <a16:creationId xmlns:a16="http://schemas.microsoft.com/office/drawing/2014/main" id="{C6D884FA-4558-D8D1-BC28-0CEF539196C0}"/>
+                </a:ext>
+              </a:extLst>
+            </p:cNvPr>
+            <p:cNvPicPr>
+              <a:picLocks noChangeAspect="1" noChangeArrowheads="1"/>
+            </p:cNvPicPr>
+            <p:nvPr/>
+          </p:nvPicPr>
+          <p:blipFill>
+            <a:blip r:embed="rId2">
+              <a:extLst>
+                <a:ext uri="{28A0092B-C50C-407E-A947-70E740481C1C}">
+                  <a14:useLocalDpi xmlns:a14="http://schemas.microsoft.com/office/drawing/2010/main" val="0"/>
+                </a:ext>
+              </a:extLst>
+            </a:blip>
+            <a:srcRect/>
+            <a:stretch>
+              <a:fillRect/>
+            </a:stretch>
+          </p:blipFill>
+          <p:spPr bwMode="auto">
+            <a:xfrm>
+              <a:off x="7472867" y="2698018"/>
+              <a:ext cx="578462" cy="655224"/>
+            </a:xfrm>
+            <a:prstGeom prst="rect">
+              <a:avLst/>
+            </a:prstGeom>
+            <a:noFill/>
+            <a:extLst>
+              <a:ext uri="{909E8E84-426E-40DD-AFC4-6F175D3DCCD1}">
+                <a14:hiddenFill xmlns:a14="http://schemas.microsoft.com/office/drawing/2010/main">
+                  <a:solidFill>
+                    <a:srgbClr val="FFFFFF"/>
+                  </a:solidFill>
+                </a14:hiddenFill>
+              </a:ext>
+            </a:extLst>
+          </p:spPr>
+        </p:pic>
+        <p:pic>
+          <p:nvPicPr>
+            <p:cNvPr id="51" name="Picture 18" descr="Database Icons - Free SVG &amp; PNG Database Images - Noun Project">
+              <a:extLst>
+                <a:ext uri="{FF2B5EF4-FFF2-40B4-BE49-F238E27FC236}">
+                  <a16:creationId xmlns:a16="http://schemas.microsoft.com/office/drawing/2014/main" id="{183D7FE1-F99C-A19F-54EB-6D7173E95841}"/>
+                </a:ext>
+              </a:extLst>
+            </p:cNvPr>
+            <p:cNvPicPr>
+              <a:picLocks noChangeAspect="1" noChangeArrowheads="1"/>
+            </p:cNvPicPr>
+            <p:nvPr/>
+          </p:nvPicPr>
+          <p:blipFill>
+            <a:blip r:embed="rId3">
+              <a:extLst>
+                <a:ext uri="{28A0092B-C50C-407E-A947-70E740481C1C}">
+                  <a14:useLocalDpi xmlns:a14="http://schemas.microsoft.com/office/drawing/2010/main" val="0"/>
+                </a:ext>
+              </a:extLst>
+            </a:blip>
+            <a:srcRect/>
+            <a:stretch>
+              <a:fillRect/>
+            </a:stretch>
+          </p:blipFill>
+          <p:spPr bwMode="auto">
+            <a:xfrm>
+              <a:off x="7183635" y="2890508"/>
+              <a:ext cx="578462" cy="578462"/>
+            </a:xfrm>
+            <a:prstGeom prst="rect">
+              <a:avLst/>
+            </a:prstGeom>
+            <a:noFill/>
+            <a:extLst>
+              <a:ext uri="{909E8E84-426E-40DD-AFC4-6F175D3DCCD1}">
+                <a14:hiddenFill xmlns:a14="http://schemas.microsoft.com/office/drawing/2010/main">
+                  <a:solidFill>
+                    <a:srgbClr val="FFFFFF"/>
+                  </a:solidFill>
+                </a14:hiddenFill>
+              </a:ext>
+            </a:extLst>
+          </p:spPr>
+        </p:pic>
+      </p:grpSp>
+      <p:sp>
+        <p:nvSpPr>
+          <p:cNvPr id="53" name="TextBox 52">
+            <a:extLst>
+              <a:ext uri="{FF2B5EF4-FFF2-40B4-BE49-F238E27FC236}">
+                <a16:creationId xmlns:a16="http://schemas.microsoft.com/office/drawing/2014/main" id="{E3C0C3A7-3B6B-7ABD-C071-A6A3F81588B0}"/>
+              </a:ext>
+            </a:extLst>
+          </p:cNvPr>
+          <p:cNvSpPr txBox="1"/>
+          <p:nvPr/>
+        </p:nvSpPr>
+        <p:spPr>
+          <a:xfrm>
+            <a:off x="9630460" y="3068191"/>
+            <a:ext cx="1300915" cy="523220"/>
+          </a:xfrm>
+          <a:prstGeom prst="rect">
+            <a:avLst/>
+          </a:prstGeom>
+          <a:noFill/>
+        </p:spPr>
+        <p:txBody>
+          <a:bodyPr wrap="square" rtlCol="0">
+            <a:spAutoFit/>
+          </a:bodyPr>
+          <a:lstStyle/>
+          <a:p>
+            <a:pPr algn="ctr"/>
+            <a:r>
+              <a:rPr lang="en-US" sz="1400" b="1" dirty="0"/>
+              <a:t>Reporting System</a:t>
+            </a:r>
+          </a:p>
+        </p:txBody>
+      </p:sp>
+      <p:grpSp>
+        <p:nvGrpSpPr>
+          <p:cNvPr id="6" name="Group 5">
+            <a:extLst>
+              <a:ext uri="{FF2B5EF4-FFF2-40B4-BE49-F238E27FC236}">
+                <a16:creationId xmlns:a16="http://schemas.microsoft.com/office/drawing/2014/main" id="{CF2B8A56-A7DB-20D6-FB81-8D18DAC9A808}"/>
+              </a:ext>
+            </a:extLst>
+          </p:cNvPr>
+          <p:cNvGrpSpPr/>
+          <p:nvPr/>
+        </p:nvGrpSpPr>
+        <p:grpSpPr>
+          <a:xfrm>
+            <a:off x="972086" y="3848158"/>
+            <a:ext cx="751185" cy="1088105"/>
+            <a:chOff x="1505690" y="1527538"/>
+            <a:chExt cx="563389" cy="816079"/>
+          </a:xfrm>
+        </p:grpSpPr>
+        <p:pic>
+          <p:nvPicPr>
+            <p:cNvPr id="7" name="Picture 6" descr="Download Free Authority Icons - SVG and PNG formats">
+              <a:extLst>
+                <a:ext uri="{FF2B5EF4-FFF2-40B4-BE49-F238E27FC236}">
+                  <a16:creationId xmlns:a16="http://schemas.microsoft.com/office/drawing/2014/main" id="{B8302B51-ADE7-B8C2-EE23-6721D094013E}"/>
+                </a:ext>
+              </a:extLst>
+            </p:cNvPr>
+            <p:cNvPicPr>
+              <a:picLocks noChangeAspect="1"/>
+            </p:cNvPicPr>
+            <p:nvPr/>
+          </p:nvPicPr>
+          <p:blipFill>
+            <a:blip r:embed="rId4"/>
+            <a:stretch>
+              <a:fillRect/>
+            </a:stretch>
+          </p:blipFill>
+          <p:spPr>
+            <a:xfrm>
+              <a:off x="1797235" y="1979603"/>
+              <a:ext cx="271844" cy="271844"/>
+            </a:xfrm>
+            <a:prstGeom prst="rect">
+              <a:avLst/>
+            </a:prstGeom>
+          </p:spPr>
+        </p:pic>
+        <p:pic>
+          <p:nvPicPr>
+            <p:cNvPr id="8" name="Picture 7" descr="Governance - Free buildings icons">
+              <a:extLst>
+                <a:ext uri="{FF2B5EF4-FFF2-40B4-BE49-F238E27FC236}">
+                  <a16:creationId xmlns:a16="http://schemas.microsoft.com/office/drawing/2014/main" id="{23C72685-E7B6-03AC-CC60-97C25B7BFD10}"/>
+                </a:ext>
+              </a:extLst>
+            </p:cNvPr>
+            <p:cNvPicPr>
+              <a:picLocks noChangeAspect="1"/>
+            </p:cNvPicPr>
+            <p:nvPr/>
+          </p:nvPicPr>
+          <p:blipFill>
+            <a:blip r:embed="rId5"/>
+            <a:stretch>
+              <a:fillRect/>
+            </a:stretch>
+          </p:blipFill>
+          <p:spPr>
+            <a:xfrm>
+              <a:off x="1511078" y="1527538"/>
+              <a:ext cx="503071" cy="503071"/>
+            </a:xfrm>
+            <a:prstGeom prst="rect">
+              <a:avLst/>
+            </a:prstGeom>
+          </p:spPr>
+        </p:pic>
+        <p:pic>
+          <p:nvPicPr>
+            <p:cNvPr id="9" name="Picture 8" descr="measure Icon - Free PNG &amp; SVG 290695 - Noun Project">
+              <a:extLst>
+                <a:ext uri="{FF2B5EF4-FFF2-40B4-BE49-F238E27FC236}">
+                  <a16:creationId xmlns:a16="http://schemas.microsoft.com/office/drawing/2014/main" id="{A0542AB3-286E-5A56-68A2-3983432CBA23}"/>
+                </a:ext>
+              </a:extLst>
+            </p:cNvPr>
+            <p:cNvPicPr>
+              <a:picLocks noChangeAspect="1"/>
+            </p:cNvPicPr>
+            <p:nvPr/>
+          </p:nvPicPr>
+          <p:blipFill>
+            <a:blip r:embed="rId6"/>
+            <a:stretch>
+              <a:fillRect/>
+            </a:stretch>
+          </p:blipFill>
+          <p:spPr>
+            <a:xfrm>
+              <a:off x="1505690" y="1982071"/>
+              <a:ext cx="361546" cy="361546"/>
+            </a:xfrm>
+            <a:prstGeom prst="rect">
+              <a:avLst/>
+            </a:prstGeom>
+          </p:spPr>
+        </p:pic>
+      </p:grpSp>
+      <p:sp>
+        <p:nvSpPr>
+          <p:cNvPr id="10" name="TextBox 9">
+            <a:extLst>
+              <a:ext uri="{FF2B5EF4-FFF2-40B4-BE49-F238E27FC236}">
+                <a16:creationId xmlns:a16="http://schemas.microsoft.com/office/drawing/2014/main" id="{1DB0F79A-9AF4-1FE2-376E-25EC32B2A3C2}"/>
+              </a:ext>
+            </a:extLst>
+          </p:cNvPr>
+          <p:cNvSpPr txBox="1"/>
+          <p:nvPr/>
+        </p:nvSpPr>
+        <p:spPr>
+          <a:xfrm>
+            <a:off x="702892" y="3024084"/>
+            <a:ext cx="1315841" cy="523220"/>
+          </a:xfrm>
+          <a:prstGeom prst="rect">
+            <a:avLst/>
+          </a:prstGeom>
+          <a:noFill/>
+        </p:spPr>
+        <p:txBody>
+          <a:bodyPr wrap="square" rtlCol="0">
+            <a:spAutoFit/>
+          </a:bodyPr>
+          <a:lstStyle/>
+          <a:p>
+            <a:pPr algn="ctr"/>
+            <a:r>
+              <a:rPr lang="en-US" sz="1400" b="1" dirty="0"/>
+              <a:t>Measure Authority</a:t>
+            </a:r>
+          </a:p>
+        </p:txBody>
+      </p:sp>
+      <p:sp>
+        <p:nvSpPr>
+          <p:cNvPr id="11" name="TextBox 10">
+            <a:extLst>
+              <a:ext uri="{FF2B5EF4-FFF2-40B4-BE49-F238E27FC236}">
+                <a16:creationId xmlns:a16="http://schemas.microsoft.com/office/drawing/2014/main" id="{ACE43897-7350-60D7-D11F-0AFEEB8CB8D2}"/>
+              </a:ext>
+            </a:extLst>
+          </p:cNvPr>
+          <p:cNvSpPr txBox="1"/>
+          <p:nvPr/>
+        </p:nvSpPr>
+        <p:spPr>
+          <a:xfrm>
+            <a:off x="884121" y="2200011"/>
+            <a:ext cx="1315841" cy="523028"/>
+          </a:xfrm>
+          <a:prstGeom prst="rect">
+            <a:avLst/>
+          </a:prstGeom>
+          <a:noFill/>
+        </p:spPr>
+        <p:txBody>
+          <a:bodyPr wrap="square" rtlCol="0">
+            <a:spAutoFit/>
+          </a:bodyPr>
+          <a:lstStyle/>
+          <a:p>
+            <a:pPr algn="ctr"/>
+            <a:r>
+              <a:rPr lang="en-US" sz="933" dirty="0"/>
+              <a:t>Measure Authority shares </a:t>
+            </a:r>
+            <a:r>
+              <a:rPr lang="en-US" sz="933" b="1" dirty="0"/>
+              <a:t>Measure Specifications</a:t>
+            </a:r>
+          </a:p>
+        </p:txBody>
+      </p:sp>
+      <p:sp>
+        <p:nvSpPr>
+          <p:cNvPr id="13" name="Oval 12">
+            <a:extLst>
+              <a:ext uri="{FF2B5EF4-FFF2-40B4-BE49-F238E27FC236}">
+                <a16:creationId xmlns:a16="http://schemas.microsoft.com/office/drawing/2014/main" id="{8359C579-7872-96AF-F4BE-7406E61ADD99}"/>
+              </a:ext>
+            </a:extLst>
+          </p:cNvPr>
+          <p:cNvSpPr/>
+          <p:nvPr/>
+        </p:nvSpPr>
+        <p:spPr>
+          <a:xfrm>
+            <a:off x="707553" y="2364478"/>
+            <a:ext cx="233932" cy="225065"/>
+          </a:xfrm>
+          <a:prstGeom prst="ellipse">
+            <a:avLst/>
+          </a:prstGeom>
+        </p:spPr>
+        <p:style>
+          <a:lnRef idx="2">
+            <a:schemeClr val="accent1">
+              <a:shade val="15000"/>
+            </a:schemeClr>
+          </a:lnRef>
+          <a:fillRef idx="1">
+            <a:schemeClr val="accent1"/>
+          </a:fillRef>
+          <a:effectRef idx="0">
+            <a:schemeClr val="accent1"/>
+          </a:effectRef>
+          <a:fontRef idx="minor">
+            <a:schemeClr val="lt1"/>
+          </a:fontRef>
+        </p:style>
+        <p:txBody>
+          <a:bodyPr rtlCol="0" anchor="ctr"/>
+          <a:lstStyle/>
+          <a:p>
+            <a:pPr algn="ctr"/>
+            <a:r>
+              <a:rPr lang="en-US" sz="1333" dirty="0"/>
+              <a:t>1</a:t>
+            </a:r>
+          </a:p>
+        </p:txBody>
+      </p:sp>
+      <p:grpSp>
+        <p:nvGrpSpPr>
+          <p:cNvPr id="52" name="Group 51">
+            <a:extLst>
+              <a:ext uri="{FF2B5EF4-FFF2-40B4-BE49-F238E27FC236}">
+                <a16:creationId xmlns:a16="http://schemas.microsoft.com/office/drawing/2014/main" id="{6C5A5F67-5DC7-6D26-677D-098E2D130934}"/>
+              </a:ext>
+            </a:extLst>
+          </p:cNvPr>
+          <p:cNvGrpSpPr/>
+          <p:nvPr/>
+        </p:nvGrpSpPr>
+        <p:grpSpPr>
+          <a:xfrm>
+            <a:off x="5312419" y="3620927"/>
+            <a:ext cx="771283" cy="1542565"/>
+            <a:chOff x="3458848" y="2412749"/>
+            <a:chExt cx="578462" cy="1156924"/>
+          </a:xfrm>
+        </p:grpSpPr>
+        <p:pic>
+          <p:nvPicPr>
+            <p:cNvPr id="17" name="Picture 2" descr="Hospital buildings - Free medical icons">
+              <a:extLst>
+                <a:ext uri="{FF2B5EF4-FFF2-40B4-BE49-F238E27FC236}">
+                  <a16:creationId xmlns:a16="http://schemas.microsoft.com/office/drawing/2014/main" id="{2D1FB4C5-6BBE-C4EB-2DF1-BA0F2767584C}"/>
+                </a:ext>
+              </a:extLst>
+            </p:cNvPr>
+            <p:cNvPicPr>
+              <a:picLocks noChangeAspect="1" noChangeArrowheads="1"/>
+            </p:cNvPicPr>
+            <p:nvPr/>
+          </p:nvPicPr>
+          <p:blipFill>
+            <a:blip r:embed="rId7">
+              <a:extLst>
+                <a:ext uri="{28A0092B-C50C-407E-A947-70E740481C1C}">
+                  <a14:useLocalDpi xmlns:a14="http://schemas.microsoft.com/office/drawing/2010/main" val="0"/>
+                </a:ext>
+              </a:extLst>
+            </a:blip>
+            <a:srcRect/>
+            <a:stretch>
+              <a:fillRect/>
+            </a:stretch>
+          </p:blipFill>
+          <p:spPr bwMode="auto">
+            <a:xfrm flipH="1">
+              <a:off x="3458848" y="2412749"/>
+              <a:ext cx="578462" cy="578462"/>
+            </a:xfrm>
+            <a:prstGeom prst="rect">
+              <a:avLst/>
+            </a:prstGeom>
+            <a:noFill/>
+            <a:extLst>
+              <a:ext uri="{909E8E84-426E-40DD-AFC4-6F175D3DCCD1}">
+                <a14:hiddenFill xmlns:a14="http://schemas.microsoft.com/office/drawing/2010/main">
+                  <a:solidFill>
+                    <a:srgbClr val="FFFFFF"/>
+                  </a:solidFill>
+                </a14:hiddenFill>
+              </a:ext>
+            </a:extLst>
+          </p:spPr>
+        </p:pic>
+        <p:pic>
+          <p:nvPicPr>
+            <p:cNvPr id="19" name="Picture 4" descr="Clinic Icons - Free SVG &amp; PNG Clinic Images - Noun Project">
+              <a:extLst>
+                <a:ext uri="{FF2B5EF4-FFF2-40B4-BE49-F238E27FC236}">
+                  <a16:creationId xmlns:a16="http://schemas.microsoft.com/office/drawing/2014/main" id="{A906E425-6C6A-DD9A-EDEA-659CA0D445C3}"/>
+                </a:ext>
+              </a:extLst>
+            </p:cNvPr>
+            <p:cNvPicPr>
+              <a:picLocks noChangeAspect="1" noChangeArrowheads="1"/>
+            </p:cNvPicPr>
+            <p:nvPr/>
+          </p:nvPicPr>
+          <p:blipFill>
+            <a:blip r:embed="rId8">
+              <a:extLst>
+                <a:ext uri="{28A0092B-C50C-407E-A947-70E740481C1C}">
+                  <a14:useLocalDpi xmlns:a14="http://schemas.microsoft.com/office/drawing/2010/main" val="0"/>
+                </a:ext>
+              </a:extLst>
+            </a:blip>
+            <a:srcRect/>
+            <a:stretch>
+              <a:fillRect/>
+            </a:stretch>
+          </p:blipFill>
+          <p:spPr bwMode="auto">
+            <a:xfrm>
+              <a:off x="3458848" y="2991211"/>
+              <a:ext cx="578462" cy="578462"/>
+            </a:xfrm>
+            <a:prstGeom prst="rect">
+              <a:avLst/>
+            </a:prstGeom>
+            <a:noFill/>
+            <a:extLst>
+              <a:ext uri="{909E8E84-426E-40DD-AFC4-6F175D3DCCD1}">
+                <a14:hiddenFill xmlns:a14="http://schemas.microsoft.com/office/drawing/2010/main">
+                  <a:solidFill>
+                    <a:srgbClr val="FFFFFF"/>
+                  </a:solidFill>
+                </a14:hiddenFill>
+              </a:ext>
+            </a:extLst>
+          </p:spPr>
+        </p:pic>
+      </p:grpSp>
+      <p:sp>
+        <p:nvSpPr>
+          <p:cNvPr id="21" name="TextBox 20">
+            <a:extLst>
+              <a:ext uri="{FF2B5EF4-FFF2-40B4-BE49-F238E27FC236}">
+                <a16:creationId xmlns:a16="http://schemas.microsoft.com/office/drawing/2014/main" id="{941EDAD6-241B-A9F8-D763-296E71695BAB}"/>
+              </a:ext>
+            </a:extLst>
+          </p:cNvPr>
+          <p:cNvSpPr txBox="1"/>
+          <p:nvPr/>
+        </p:nvSpPr>
+        <p:spPr>
+          <a:xfrm>
+            <a:off x="5288877" y="3126720"/>
+            <a:ext cx="818366" cy="307777"/>
+          </a:xfrm>
+          <a:prstGeom prst="rect">
+            <a:avLst/>
+          </a:prstGeom>
+          <a:noFill/>
+        </p:spPr>
+        <p:txBody>
+          <a:bodyPr wrap="none" rtlCol="0">
+            <a:spAutoFit/>
+          </a:bodyPr>
+          <a:lstStyle/>
+          <a:p>
+            <a:pPr algn="ctr"/>
+            <a:r>
+              <a:rPr lang="en-US" sz="1400" b="1" dirty="0"/>
+              <a:t>Provider</a:t>
+            </a:r>
+          </a:p>
+        </p:txBody>
+      </p:sp>
+      <p:pic>
+        <p:nvPicPr>
+          <p:cNvPr id="23" name="Picture 14" descr="Health Insurance Icon SVG Vector &amp; PNG Free Download | UXWing">
+            <a:extLst>
+              <a:ext uri="{FF2B5EF4-FFF2-40B4-BE49-F238E27FC236}">
+                <a16:creationId xmlns:a16="http://schemas.microsoft.com/office/drawing/2014/main" id="{1068D165-7E8F-26DF-B354-6B8653D94650}"/>
+              </a:ext>
+            </a:extLst>
+          </p:cNvPr>
+          <p:cNvPicPr>
+            <a:picLocks noChangeAspect="1" noChangeArrowheads="1"/>
+          </p:cNvPicPr>
+          <p:nvPr/>
+        </p:nvPicPr>
+        <p:blipFill>
+          <a:blip r:embed="rId9">
+            <a:extLst>
+              <a:ext uri="{28A0092B-C50C-407E-A947-70E740481C1C}">
+                <a14:useLocalDpi xmlns:a14="http://schemas.microsoft.com/office/drawing/2010/main" val="0"/>
+              </a:ext>
+            </a:extLst>
+          </a:blip>
+          <a:srcRect/>
+          <a:stretch>
+            <a:fillRect/>
+          </a:stretch>
+        </p:blipFill>
+        <p:spPr bwMode="auto">
+          <a:xfrm>
+            <a:off x="7595163" y="4006568"/>
+            <a:ext cx="788653" cy="771283"/>
+          </a:xfrm>
+          <a:prstGeom prst="rect">
+            <a:avLst/>
+          </a:prstGeom>
+          <a:noFill/>
+          <a:extLst>
+            <a:ext uri="{909E8E84-426E-40DD-AFC4-6F175D3DCCD1}">
+              <a14:hiddenFill xmlns:a14="http://schemas.microsoft.com/office/drawing/2010/main">
+                <a:solidFill>
+                  <a:srgbClr val="FFFFFF"/>
+                </a:solidFill>
+              </a14:hiddenFill>
+            </a:ext>
+          </a:extLst>
+        </p:spPr>
+      </p:pic>
+      <p:sp>
+        <p:nvSpPr>
+          <p:cNvPr id="25" name="TextBox 24">
+            <a:extLst>
+              <a:ext uri="{FF2B5EF4-FFF2-40B4-BE49-F238E27FC236}">
+                <a16:creationId xmlns:a16="http://schemas.microsoft.com/office/drawing/2014/main" id="{7C66FDCC-B03C-57C8-905D-877DDAF98308}"/>
+              </a:ext>
+            </a:extLst>
+          </p:cNvPr>
+          <p:cNvSpPr txBox="1"/>
+          <p:nvPr/>
+        </p:nvSpPr>
+        <p:spPr>
+          <a:xfrm>
+            <a:off x="7689952" y="3175913"/>
+            <a:ext cx="599075" cy="307777"/>
+          </a:xfrm>
+          <a:prstGeom prst="rect">
+            <a:avLst/>
+          </a:prstGeom>
+          <a:noFill/>
+        </p:spPr>
+        <p:txBody>
+          <a:bodyPr wrap="none" rtlCol="0">
+            <a:spAutoFit/>
+          </a:bodyPr>
+          <a:lstStyle/>
+          <a:p>
+            <a:pPr algn="ctr"/>
+            <a:r>
+              <a:rPr lang="en-US" sz="1400" b="1" dirty="0"/>
+              <a:t>Payer</a:t>
+            </a:r>
+          </a:p>
+        </p:txBody>
+      </p:sp>
+      <p:sp>
+        <p:nvSpPr>
+          <p:cNvPr id="33" name="TextBox 32">
+            <a:extLst>
+              <a:ext uri="{FF2B5EF4-FFF2-40B4-BE49-F238E27FC236}">
+                <a16:creationId xmlns:a16="http://schemas.microsoft.com/office/drawing/2014/main" id="{F3E8C2A3-85F8-4F19-3D61-56618A60F598}"/>
+              </a:ext>
+            </a:extLst>
+          </p:cNvPr>
+          <p:cNvSpPr txBox="1"/>
+          <p:nvPr/>
+        </p:nvSpPr>
+        <p:spPr>
+          <a:xfrm>
+            <a:off x="2726733" y="2200011"/>
+            <a:ext cx="1610225" cy="379463"/>
+          </a:xfrm>
+          <a:prstGeom prst="rect">
+            <a:avLst/>
+          </a:prstGeom>
+          <a:noFill/>
+        </p:spPr>
+        <p:txBody>
+          <a:bodyPr wrap="square" rtlCol="0">
+            <a:spAutoFit/>
+          </a:bodyPr>
+          <a:lstStyle/>
+          <a:p>
+            <a:pPr algn="ctr"/>
+            <a:r>
+              <a:rPr lang="en-US" sz="933" dirty="0"/>
+              <a:t>Terminology Authority shares </a:t>
+            </a:r>
+            <a:r>
+              <a:rPr lang="en-US" sz="933" b="1" dirty="0"/>
+              <a:t>Value Set Specifications</a:t>
+            </a:r>
+          </a:p>
+        </p:txBody>
+      </p:sp>
+      <p:sp>
+        <p:nvSpPr>
+          <p:cNvPr id="38" name="Oval 37">
+            <a:extLst>
+              <a:ext uri="{FF2B5EF4-FFF2-40B4-BE49-F238E27FC236}">
+                <a16:creationId xmlns:a16="http://schemas.microsoft.com/office/drawing/2014/main" id="{3DC325AD-AFF0-A2F8-D8B0-8E08B4754E1D}"/>
+              </a:ext>
+            </a:extLst>
+          </p:cNvPr>
+          <p:cNvSpPr/>
+          <p:nvPr/>
+        </p:nvSpPr>
+        <p:spPr>
+          <a:xfrm>
+            <a:off x="2609767" y="2351904"/>
+            <a:ext cx="233932" cy="225065"/>
+          </a:xfrm>
+          <a:prstGeom prst="ellipse">
+            <a:avLst/>
+          </a:prstGeom>
+        </p:spPr>
+        <p:style>
+          <a:lnRef idx="2">
+            <a:schemeClr val="accent1">
+              <a:shade val="15000"/>
+            </a:schemeClr>
+          </a:lnRef>
+          <a:fillRef idx="1">
+            <a:schemeClr val="accent1"/>
+          </a:fillRef>
+          <a:effectRef idx="0">
+            <a:schemeClr val="accent1"/>
+          </a:effectRef>
+          <a:fontRef idx="minor">
+            <a:schemeClr val="lt1"/>
+          </a:fontRef>
+        </p:style>
+        <p:txBody>
+          <a:bodyPr rtlCol="0" anchor="ctr"/>
+          <a:lstStyle/>
+          <a:p>
+            <a:pPr algn="ctr"/>
+            <a:r>
+              <a:rPr lang="en-US" sz="1333" dirty="0"/>
+              <a:t>2</a:t>
+            </a:r>
+          </a:p>
+        </p:txBody>
+      </p:sp>
+      <p:grpSp>
+        <p:nvGrpSpPr>
+          <p:cNvPr id="46" name="Group 45">
+            <a:extLst>
+              <a:ext uri="{FF2B5EF4-FFF2-40B4-BE49-F238E27FC236}">
+                <a16:creationId xmlns:a16="http://schemas.microsoft.com/office/drawing/2014/main" id="{40A9DBE9-A727-800D-39AF-EB786E703344}"/>
+              </a:ext>
+            </a:extLst>
+          </p:cNvPr>
+          <p:cNvGrpSpPr/>
+          <p:nvPr/>
+        </p:nvGrpSpPr>
+        <p:grpSpPr>
+          <a:xfrm>
+            <a:off x="3234733" y="3926459"/>
+            <a:ext cx="566225" cy="931503"/>
+            <a:chOff x="1399168" y="2648192"/>
+            <a:chExt cx="424669" cy="698627"/>
+          </a:xfrm>
+        </p:grpSpPr>
+        <p:pic>
+          <p:nvPicPr>
+            <p:cNvPr id="40" name="Picture 39" descr="Dictionary - Free education icons">
+              <a:extLst>
+                <a:ext uri="{FF2B5EF4-FFF2-40B4-BE49-F238E27FC236}">
+                  <a16:creationId xmlns:a16="http://schemas.microsoft.com/office/drawing/2014/main" id="{9B8B535F-AFF7-4056-0A02-BE8F47EC3352}"/>
+                </a:ext>
+              </a:extLst>
+            </p:cNvPr>
+            <p:cNvPicPr>
+              <a:picLocks noChangeAspect="1"/>
+            </p:cNvPicPr>
+            <p:nvPr/>
+          </p:nvPicPr>
+          <p:blipFill>
+            <a:blip r:embed="rId10"/>
+            <a:stretch>
+              <a:fillRect/>
+            </a:stretch>
+          </p:blipFill>
+          <p:spPr>
+            <a:xfrm>
+              <a:off x="1399168" y="2648192"/>
+              <a:ext cx="424669" cy="424669"/>
+            </a:xfrm>
+            <a:prstGeom prst="rect">
+              <a:avLst/>
+            </a:prstGeom>
+          </p:spPr>
+        </p:pic>
+        <p:pic>
+          <p:nvPicPr>
+            <p:cNvPr id="44" name="Picture 43" descr="Download Free Authority Icons - SVG and PNG formats">
+              <a:extLst>
+                <a:ext uri="{FF2B5EF4-FFF2-40B4-BE49-F238E27FC236}">
+                  <a16:creationId xmlns:a16="http://schemas.microsoft.com/office/drawing/2014/main" id="{668FEFFD-AC17-C702-9688-DAF0E8BBDD6A}"/>
+                </a:ext>
+              </a:extLst>
+            </p:cNvPr>
+            <p:cNvPicPr>
+              <a:picLocks noChangeAspect="1"/>
+            </p:cNvPicPr>
+            <p:nvPr/>
+          </p:nvPicPr>
+          <p:blipFill>
+            <a:blip r:embed="rId4"/>
+            <a:stretch>
+              <a:fillRect/>
+            </a:stretch>
+          </p:blipFill>
+          <p:spPr>
+            <a:xfrm>
+              <a:off x="1478393" y="3074975"/>
+              <a:ext cx="271844" cy="271844"/>
+            </a:xfrm>
+            <a:prstGeom prst="rect">
+              <a:avLst/>
+            </a:prstGeom>
+          </p:spPr>
+        </p:pic>
+      </p:grpSp>
+      <p:sp>
+        <p:nvSpPr>
+          <p:cNvPr id="48" name="TextBox 47">
+            <a:extLst>
+              <a:ext uri="{FF2B5EF4-FFF2-40B4-BE49-F238E27FC236}">
+                <a16:creationId xmlns:a16="http://schemas.microsoft.com/office/drawing/2014/main" id="{4FCEC59B-F261-61FE-9643-910DF40A9216}"/>
+              </a:ext>
+            </a:extLst>
+          </p:cNvPr>
+          <p:cNvSpPr txBox="1"/>
+          <p:nvPr/>
+        </p:nvSpPr>
+        <p:spPr>
+          <a:xfrm>
+            <a:off x="2859924" y="3066930"/>
+            <a:ext cx="1315841" cy="523220"/>
+          </a:xfrm>
+          <a:prstGeom prst="rect">
+            <a:avLst/>
+          </a:prstGeom>
+          <a:noFill/>
+        </p:spPr>
+        <p:txBody>
+          <a:bodyPr wrap="square" rtlCol="0">
+            <a:spAutoFit/>
+          </a:bodyPr>
+          <a:lstStyle/>
+          <a:p>
+            <a:pPr algn="ctr"/>
+            <a:r>
+              <a:rPr lang="en-US" sz="1400" b="1" dirty="0"/>
+              <a:t>Terminology Authority</a:t>
+            </a:r>
+          </a:p>
+        </p:txBody>
+      </p:sp>
+      <p:sp>
+        <p:nvSpPr>
+          <p:cNvPr id="56" name="TextBox 55">
+            <a:extLst>
+              <a:ext uri="{FF2B5EF4-FFF2-40B4-BE49-F238E27FC236}">
+                <a16:creationId xmlns:a16="http://schemas.microsoft.com/office/drawing/2014/main" id="{16DEC2F3-1A36-47DA-74FC-2F914E056967}"/>
+              </a:ext>
+            </a:extLst>
+          </p:cNvPr>
+          <p:cNvSpPr txBox="1"/>
+          <p:nvPr/>
+        </p:nvSpPr>
+        <p:spPr>
+          <a:xfrm>
+            <a:off x="4988074" y="2297367"/>
+            <a:ext cx="1610225" cy="379463"/>
+          </a:xfrm>
+          <a:prstGeom prst="rect">
+            <a:avLst/>
+          </a:prstGeom>
+          <a:noFill/>
+        </p:spPr>
+        <p:txBody>
+          <a:bodyPr wrap="square" rtlCol="0">
+            <a:spAutoFit/>
+          </a:bodyPr>
+          <a:lstStyle/>
+          <a:p>
+            <a:pPr algn="ctr"/>
+            <a:r>
+              <a:rPr lang="en-US" sz="933" dirty="0"/>
+              <a:t>Provider and Payer agree on </a:t>
+            </a:r>
+            <a:r>
+              <a:rPr lang="en-US" sz="933" b="1" dirty="0"/>
+              <a:t>Measures to use</a:t>
+            </a:r>
+          </a:p>
+        </p:txBody>
+      </p:sp>
+      <p:sp>
+        <p:nvSpPr>
+          <p:cNvPr id="62" name="Oval 61">
+            <a:extLst>
+              <a:ext uri="{FF2B5EF4-FFF2-40B4-BE49-F238E27FC236}">
+                <a16:creationId xmlns:a16="http://schemas.microsoft.com/office/drawing/2014/main" id="{0E9158CA-1F0B-066B-F077-A582EF9EC138}"/>
+              </a:ext>
+            </a:extLst>
+          </p:cNvPr>
+          <p:cNvSpPr/>
+          <p:nvPr/>
+        </p:nvSpPr>
+        <p:spPr>
+          <a:xfrm>
+            <a:off x="4819385" y="2377446"/>
+            <a:ext cx="233932" cy="225065"/>
+          </a:xfrm>
+          <a:prstGeom prst="ellipse">
+            <a:avLst/>
+          </a:prstGeom>
+        </p:spPr>
+        <p:style>
+          <a:lnRef idx="2">
+            <a:schemeClr val="accent1">
+              <a:shade val="15000"/>
+            </a:schemeClr>
+          </a:lnRef>
+          <a:fillRef idx="1">
+            <a:schemeClr val="accent1"/>
+          </a:fillRef>
+          <a:effectRef idx="0">
+            <a:schemeClr val="accent1"/>
+          </a:effectRef>
+          <a:fontRef idx="minor">
+            <a:schemeClr val="lt1"/>
+          </a:fontRef>
+        </p:style>
+        <p:txBody>
+          <a:bodyPr rtlCol="0" anchor="ctr"/>
+          <a:lstStyle/>
+          <a:p>
+            <a:pPr algn="ctr"/>
+            <a:r>
+              <a:rPr lang="en-US" sz="1333" dirty="0"/>
+              <a:t>3</a:t>
+            </a:r>
+          </a:p>
+        </p:txBody>
+      </p:sp>
+      <p:sp>
+        <p:nvSpPr>
+          <p:cNvPr id="66" name="TextBox 65">
+            <a:extLst>
+              <a:ext uri="{FF2B5EF4-FFF2-40B4-BE49-F238E27FC236}">
+                <a16:creationId xmlns:a16="http://schemas.microsoft.com/office/drawing/2014/main" id="{F7E963F3-B16E-E790-C3B1-074182D634E9}"/>
+              </a:ext>
+            </a:extLst>
+          </p:cNvPr>
+          <p:cNvSpPr txBox="1"/>
+          <p:nvPr/>
+        </p:nvSpPr>
+        <p:spPr>
+          <a:xfrm>
+            <a:off x="7224837" y="2314309"/>
+            <a:ext cx="1610225" cy="235898"/>
+          </a:xfrm>
+          <a:prstGeom prst="rect">
+            <a:avLst/>
+          </a:prstGeom>
+          <a:noFill/>
+        </p:spPr>
+        <p:txBody>
+          <a:bodyPr wrap="square" rtlCol="0">
+            <a:spAutoFit/>
+          </a:bodyPr>
+          <a:lstStyle/>
+          <a:p>
+            <a:pPr algn="ctr"/>
+            <a:r>
+              <a:rPr lang="en-US" sz="933" dirty="0"/>
+              <a:t>Payer determines </a:t>
+            </a:r>
+            <a:r>
+              <a:rPr lang="en-US" sz="933" b="1" dirty="0"/>
+              <a:t>attribution</a:t>
+            </a:r>
+          </a:p>
+        </p:txBody>
+      </p:sp>
+      <p:sp>
+        <p:nvSpPr>
+          <p:cNvPr id="71" name="Oval 70">
+            <a:extLst>
+              <a:ext uri="{FF2B5EF4-FFF2-40B4-BE49-F238E27FC236}">
+                <a16:creationId xmlns:a16="http://schemas.microsoft.com/office/drawing/2014/main" id="{F6675FD5-E165-8CFE-4368-6A729BBA8318}"/>
+              </a:ext>
+            </a:extLst>
+          </p:cNvPr>
+          <p:cNvSpPr/>
+          <p:nvPr/>
+        </p:nvSpPr>
+        <p:spPr>
+          <a:xfrm>
+            <a:off x="7056147" y="2394388"/>
+            <a:ext cx="233932" cy="225065"/>
+          </a:xfrm>
+          <a:prstGeom prst="ellipse">
+            <a:avLst/>
+          </a:prstGeom>
+        </p:spPr>
+        <p:style>
+          <a:lnRef idx="2">
+            <a:schemeClr val="accent1">
+              <a:shade val="15000"/>
+            </a:schemeClr>
+          </a:lnRef>
+          <a:fillRef idx="1">
+            <a:schemeClr val="accent1"/>
+          </a:fillRef>
+          <a:effectRef idx="0">
+            <a:schemeClr val="accent1"/>
+          </a:effectRef>
+          <a:fontRef idx="minor">
+            <a:schemeClr val="lt1"/>
+          </a:fontRef>
+        </p:style>
+        <p:txBody>
+          <a:bodyPr rtlCol="0" anchor="ctr"/>
+          <a:lstStyle/>
+          <a:p>
+            <a:pPr algn="ctr"/>
+            <a:r>
+              <a:rPr lang="en-US" sz="1333" dirty="0"/>
+              <a:t>4</a:t>
+            </a:r>
+          </a:p>
+        </p:txBody>
+      </p:sp>
+      <p:sp>
+        <p:nvSpPr>
+          <p:cNvPr id="75" name="TextBox 74">
+            <a:extLst>
+              <a:ext uri="{FF2B5EF4-FFF2-40B4-BE49-F238E27FC236}">
+                <a16:creationId xmlns:a16="http://schemas.microsoft.com/office/drawing/2014/main" id="{3CE0035B-576E-5E84-F506-E0A5AE4822CD}"/>
+              </a:ext>
+            </a:extLst>
+          </p:cNvPr>
+          <p:cNvSpPr txBox="1"/>
+          <p:nvPr/>
+        </p:nvSpPr>
+        <p:spPr>
+          <a:xfrm>
+            <a:off x="9654868" y="2314309"/>
+            <a:ext cx="1610225" cy="379463"/>
+          </a:xfrm>
+          <a:prstGeom prst="rect">
+            <a:avLst/>
+          </a:prstGeom>
+          <a:noFill/>
+        </p:spPr>
+        <p:txBody>
+          <a:bodyPr wrap="square" rtlCol="0">
+            <a:spAutoFit/>
+          </a:bodyPr>
+          <a:lstStyle/>
+          <a:p>
+            <a:pPr algn="ctr"/>
+            <a:r>
+              <a:rPr lang="en-US" sz="933" dirty="0"/>
+              <a:t>Reporting System </a:t>
+            </a:r>
+            <a:r>
+              <a:rPr lang="en-US" sz="933" b="1" dirty="0"/>
+              <a:t>configures measures</a:t>
+            </a:r>
+          </a:p>
+        </p:txBody>
+      </p:sp>
+      <p:sp>
+        <p:nvSpPr>
+          <p:cNvPr id="78" name="Oval 77">
+            <a:extLst>
+              <a:ext uri="{FF2B5EF4-FFF2-40B4-BE49-F238E27FC236}">
+                <a16:creationId xmlns:a16="http://schemas.microsoft.com/office/drawing/2014/main" id="{0978A015-9469-7E77-542F-B236CA189B9D}"/>
+              </a:ext>
+            </a:extLst>
+          </p:cNvPr>
+          <p:cNvSpPr/>
+          <p:nvPr/>
+        </p:nvSpPr>
+        <p:spPr>
+          <a:xfrm>
+            <a:off x="9486178" y="2394388"/>
+            <a:ext cx="233932" cy="225065"/>
+          </a:xfrm>
+          <a:prstGeom prst="ellipse">
+            <a:avLst/>
+          </a:prstGeom>
+        </p:spPr>
+        <p:style>
+          <a:lnRef idx="2">
+            <a:schemeClr val="accent1">
+              <a:shade val="15000"/>
+            </a:schemeClr>
+          </a:lnRef>
+          <a:fillRef idx="1">
+            <a:schemeClr val="accent1"/>
+          </a:fillRef>
+          <a:effectRef idx="0">
+            <a:schemeClr val="accent1"/>
+          </a:effectRef>
+          <a:fontRef idx="minor">
+            <a:schemeClr val="lt1"/>
+          </a:fontRef>
+        </p:style>
+        <p:txBody>
+          <a:bodyPr rtlCol="0" anchor="ctr"/>
+          <a:lstStyle/>
+          <a:p>
+            <a:pPr algn="ctr"/>
+            <a:r>
+              <a:rPr lang="en-US" sz="1333" dirty="0"/>
+              <a:t>5</a:t>
+            </a:r>
+          </a:p>
+        </p:txBody>
+      </p:sp>
+    </p:spTree>
+    <p:extLst>
+      <p:ext uri="{BB962C8B-B14F-4D97-AF65-F5344CB8AC3E}">
+        <p14:creationId xmlns:p14="http://schemas.microsoft.com/office/powerpoint/2010/main" val="1745988543"/>
+      </p:ext>
+    </p:extLst>
+  </p:cSld>
+  <p:clrMapOvr>
+    <a:masterClrMapping/>
+  </p:clrMapOvr>
+</p:sld>
+</file>
+
+<file path=ppt/slides/slide13.xml><?xml version="1.0" encoding="utf-8"?>
+<p:sld xmlns:a="http://schemas.openxmlformats.org/drawingml/2006/main" xmlns:r="http://schemas.openxmlformats.org/officeDocument/2006/relationships" xmlns:p="http://schemas.openxmlformats.org/presentationml/2006/main">
+  <p:cSld>
+    <p:spTree>
+      <p:nvGrpSpPr>
+        <p:cNvPr id="1" name=""/>
+        <p:cNvGrpSpPr/>
+        <p:nvPr/>
+      </p:nvGrpSpPr>
+      <p:grpSpPr>
+        <a:xfrm>
+          <a:off x="0" y="0"/>
+          <a:ext cx="0" cy="0"/>
+          <a:chOff x="0" y="0"/>
+          <a:chExt cx="0" cy="0"/>
+        </a:xfrm>
+      </p:grpSpPr>
+      <p:sp>
+        <p:nvSpPr>
+          <p:cNvPr id="2" name="Title 1">
+            <a:extLst>
+              <a:ext uri="{FF2B5EF4-FFF2-40B4-BE49-F238E27FC236}">
+                <a16:creationId xmlns:a16="http://schemas.microsoft.com/office/drawing/2014/main" id="{1000C687-1B2F-5D56-0734-B5758D2F7FC0}"/>
+              </a:ext>
+            </a:extLst>
+          </p:cNvPr>
+          <p:cNvSpPr>
+            <a:spLocks noGrp="1"/>
+          </p:cNvSpPr>
+          <p:nvPr>
+            <p:ph type="title"/>
+          </p:nvPr>
+        </p:nvSpPr>
+        <p:spPr/>
+        <p:txBody>
+          <a:bodyPr/>
+          <a:lstStyle/>
+          <a:p>
+            <a:r>
+              <a:rPr lang="en-US" dirty="0"/>
+              <a:t>Payer/Provider Reporting</a:t>
+            </a:r>
+          </a:p>
+        </p:txBody>
+      </p:sp>
+      <p:sp>
+        <p:nvSpPr>
+          <p:cNvPr id="4" name="Slide Number Placeholder 3">
+            <a:extLst>
+              <a:ext uri="{FF2B5EF4-FFF2-40B4-BE49-F238E27FC236}">
+                <a16:creationId xmlns:a16="http://schemas.microsoft.com/office/drawing/2014/main" id="{070F1C0D-83FD-13BD-CC26-1BB9F27F4325}"/>
+              </a:ext>
+            </a:extLst>
+          </p:cNvPr>
+          <p:cNvSpPr>
+            <a:spLocks noGrp="1"/>
+          </p:cNvSpPr>
+          <p:nvPr>
+            <p:ph type="sldNum" sz="quarter" idx="12"/>
+          </p:nvPr>
+        </p:nvSpPr>
+        <p:spPr/>
+        <p:txBody>
+          <a:bodyPr/>
+          <a:lstStyle/>
+          <a:p>
+            <a:fld id="{00000000-1234-1234-1234-123412341234}" type="slidenum">
+              <a:rPr lang="en-US" smtClean="0"/>
+              <a:pPr/>
+              <a:t>13</a:t>
+            </a:fld>
+            <a:endParaRPr lang="en-US" dirty="0"/>
+          </a:p>
+        </p:txBody>
+      </p:sp>
+      <p:pic>
+        <p:nvPicPr>
+          <p:cNvPr id="26" name="Picture 14" descr="Health Insurance Icon SVG Vector &amp; PNG Free Download | UXWing">
+            <a:extLst>
+              <a:ext uri="{FF2B5EF4-FFF2-40B4-BE49-F238E27FC236}">
+                <a16:creationId xmlns:a16="http://schemas.microsoft.com/office/drawing/2014/main" id="{24F0DD55-C105-1BEF-14CF-17C5C46E4368}"/>
+              </a:ext>
+            </a:extLst>
+          </p:cNvPr>
+          <p:cNvPicPr>
+            <a:picLocks noChangeAspect="1" noChangeArrowheads="1"/>
+          </p:cNvPicPr>
+          <p:nvPr/>
+        </p:nvPicPr>
+        <p:blipFill>
+          <a:blip r:embed="rId2">
+            <a:extLst>
+              <a:ext uri="{28A0092B-C50C-407E-A947-70E740481C1C}">
+                <a14:useLocalDpi xmlns:a14="http://schemas.microsoft.com/office/drawing/2010/main" val="0"/>
+              </a:ext>
+            </a:extLst>
+          </a:blip>
+          <a:srcRect/>
+          <a:stretch>
+            <a:fillRect/>
+          </a:stretch>
+        </p:blipFill>
+        <p:spPr bwMode="auto">
+          <a:xfrm>
+            <a:off x="5284920" y="3349636"/>
+            <a:ext cx="788653" cy="771283"/>
+          </a:xfrm>
+          <a:prstGeom prst="rect">
+            <a:avLst/>
+          </a:prstGeom>
+          <a:noFill/>
+          <a:extLst>
+            <a:ext uri="{909E8E84-426E-40DD-AFC4-6F175D3DCCD1}">
+              <a14:hiddenFill xmlns:a14="http://schemas.microsoft.com/office/drawing/2010/main">
+                <a:solidFill>
+                  <a:srgbClr val="FFFFFF"/>
+                </a:solidFill>
+              </a14:hiddenFill>
+            </a:ext>
+          </a:extLst>
+        </p:spPr>
+      </p:pic>
+      <p:sp>
+        <p:nvSpPr>
+          <p:cNvPr id="28" name="TextBox 27">
+            <a:extLst>
+              <a:ext uri="{FF2B5EF4-FFF2-40B4-BE49-F238E27FC236}">
+                <a16:creationId xmlns:a16="http://schemas.microsoft.com/office/drawing/2014/main" id="{8AE4B4C9-D65B-B44D-D383-9FEA2965C5BB}"/>
+              </a:ext>
+            </a:extLst>
+          </p:cNvPr>
+          <p:cNvSpPr txBox="1"/>
+          <p:nvPr/>
+        </p:nvSpPr>
+        <p:spPr>
+          <a:xfrm>
+            <a:off x="5379709" y="2455358"/>
+            <a:ext cx="599075" cy="307777"/>
+          </a:xfrm>
+          <a:prstGeom prst="rect">
+            <a:avLst/>
+          </a:prstGeom>
+          <a:noFill/>
+        </p:spPr>
+        <p:txBody>
+          <a:bodyPr wrap="none" rtlCol="0">
+            <a:spAutoFit/>
+          </a:bodyPr>
+          <a:lstStyle/>
+          <a:p>
+            <a:pPr algn="ctr"/>
+            <a:r>
+              <a:rPr lang="en-US" sz="1400" b="1" dirty="0"/>
+              <a:t>Payer</a:t>
+            </a:r>
+          </a:p>
+        </p:txBody>
+      </p:sp>
+      <p:pic>
+        <p:nvPicPr>
+          <p:cNvPr id="30" name="Picture 2" descr="Hospital buildings - Free medical icons">
+            <a:extLst>
+              <a:ext uri="{FF2B5EF4-FFF2-40B4-BE49-F238E27FC236}">
+                <a16:creationId xmlns:a16="http://schemas.microsoft.com/office/drawing/2014/main" id="{FCDB7A80-848F-6D41-6B12-014781FAE71E}"/>
+              </a:ext>
+            </a:extLst>
+          </p:cNvPr>
+          <p:cNvPicPr>
+            <a:picLocks noChangeAspect="1" noChangeArrowheads="1"/>
+          </p:cNvPicPr>
+          <p:nvPr/>
+        </p:nvPicPr>
+        <p:blipFill>
+          <a:blip r:embed="rId3">
+            <a:extLst>
+              <a:ext uri="{28A0092B-C50C-407E-A947-70E740481C1C}">
+                <a14:useLocalDpi xmlns:a14="http://schemas.microsoft.com/office/drawing/2010/main" val="0"/>
+              </a:ext>
+            </a:extLst>
+          </a:blip>
+          <a:srcRect/>
+          <a:stretch>
+            <a:fillRect/>
+          </a:stretch>
+        </p:blipFill>
+        <p:spPr bwMode="auto">
+          <a:xfrm flipH="1">
+            <a:off x="1018520" y="3046924"/>
+            <a:ext cx="771283" cy="771283"/>
+          </a:xfrm>
+          <a:prstGeom prst="rect">
+            <a:avLst/>
+          </a:prstGeom>
+          <a:noFill/>
+          <a:extLst>
+            <a:ext uri="{909E8E84-426E-40DD-AFC4-6F175D3DCCD1}">
+              <a14:hiddenFill xmlns:a14="http://schemas.microsoft.com/office/drawing/2010/main">
+                <a:solidFill>
+                  <a:srgbClr val="FFFFFF"/>
+                </a:solidFill>
+              </a14:hiddenFill>
+            </a:ext>
+          </a:extLst>
+        </p:spPr>
+      </p:pic>
+      <p:pic>
+        <p:nvPicPr>
+          <p:cNvPr id="32" name="Picture 4" descr="Clinic Icons - Free SVG &amp; PNG Clinic Images - Noun Project">
+            <a:extLst>
+              <a:ext uri="{FF2B5EF4-FFF2-40B4-BE49-F238E27FC236}">
+                <a16:creationId xmlns:a16="http://schemas.microsoft.com/office/drawing/2014/main" id="{A2F1BBE3-AC70-DB55-1746-C44F77810891}"/>
+              </a:ext>
+            </a:extLst>
+          </p:cNvPr>
+          <p:cNvPicPr>
+            <a:picLocks noChangeAspect="1" noChangeArrowheads="1"/>
+          </p:cNvPicPr>
+          <p:nvPr/>
+        </p:nvPicPr>
+        <p:blipFill>
+          <a:blip r:embed="rId4">
+            <a:extLst>
+              <a:ext uri="{28A0092B-C50C-407E-A947-70E740481C1C}">
+                <a14:useLocalDpi xmlns:a14="http://schemas.microsoft.com/office/drawing/2010/main" val="0"/>
+              </a:ext>
+            </a:extLst>
+          </a:blip>
+          <a:srcRect/>
+          <a:stretch>
+            <a:fillRect/>
+          </a:stretch>
+        </p:blipFill>
+        <p:spPr bwMode="auto">
+          <a:xfrm>
+            <a:off x="1018520" y="3818207"/>
+            <a:ext cx="771283" cy="771283"/>
+          </a:xfrm>
+          <a:prstGeom prst="rect">
+            <a:avLst/>
+          </a:prstGeom>
+          <a:noFill/>
+          <a:extLst>
+            <a:ext uri="{909E8E84-426E-40DD-AFC4-6F175D3DCCD1}">
+              <a14:hiddenFill xmlns:a14="http://schemas.microsoft.com/office/drawing/2010/main">
+                <a:solidFill>
+                  <a:srgbClr val="FFFFFF"/>
+                </a:solidFill>
+              </a14:hiddenFill>
+            </a:ext>
+          </a:extLst>
+        </p:spPr>
+      </p:pic>
+      <p:sp>
+        <p:nvSpPr>
+          <p:cNvPr id="34" name="TextBox 33">
+            <a:extLst>
+              <a:ext uri="{FF2B5EF4-FFF2-40B4-BE49-F238E27FC236}">
+                <a16:creationId xmlns:a16="http://schemas.microsoft.com/office/drawing/2014/main" id="{9E5ED287-90E7-B886-2B6D-408C08CACEF6}"/>
+              </a:ext>
+            </a:extLst>
+          </p:cNvPr>
+          <p:cNvSpPr txBox="1"/>
+          <p:nvPr/>
+        </p:nvSpPr>
+        <p:spPr>
+          <a:xfrm>
+            <a:off x="994978" y="2487113"/>
+            <a:ext cx="818366" cy="307777"/>
+          </a:xfrm>
+          <a:prstGeom prst="rect">
+            <a:avLst/>
+          </a:prstGeom>
+          <a:noFill/>
+        </p:spPr>
+        <p:txBody>
+          <a:bodyPr wrap="none" rtlCol="0">
+            <a:spAutoFit/>
+          </a:bodyPr>
+          <a:lstStyle/>
+          <a:p>
+            <a:pPr algn="ctr"/>
+            <a:r>
+              <a:rPr lang="en-US" sz="1400" b="1" dirty="0"/>
+              <a:t>Provider</a:t>
+            </a:r>
+          </a:p>
+        </p:txBody>
+      </p:sp>
+      <p:cxnSp>
+        <p:nvCxnSpPr>
+          <p:cNvPr id="36" name="Straight Connector 35">
+            <a:extLst>
+              <a:ext uri="{FF2B5EF4-FFF2-40B4-BE49-F238E27FC236}">
+                <a16:creationId xmlns:a16="http://schemas.microsoft.com/office/drawing/2014/main" id="{DF183740-770C-E751-EBF5-44A60C3FF71F}"/>
+              </a:ext>
+            </a:extLst>
+          </p:cNvPr>
+          <p:cNvCxnSpPr/>
+          <p:nvPr/>
+        </p:nvCxnSpPr>
+        <p:spPr>
+          <a:xfrm flipH="1">
+            <a:off x="1898427" y="1652317"/>
+            <a:ext cx="66503" cy="3857105"/>
+          </a:xfrm>
+          <a:prstGeom prst="line">
+            <a:avLst/>
+          </a:prstGeom>
+        </p:spPr>
+        <p:style>
+          <a:lnRef idx="3">
+            <a:schemeClr val="accent1"/>
+          </a:lnRef>
+          <a:fillRef idx="0">
+            <a:schemeClr val="accent1"/>
+          </a:fillRef>
+          <a:effectRef idx="2">
+            <a:schemeClr val="accent1"/>
+          </a:effectRef>
+          <a:fontRef idx="minor">
+            <a:schemeClr val="tx1"/>
+          </a:fontRef>
+        </p:style>
+      </p:cxnSp>
+      <p:cxnSp>
+        <p:nvCxnSpPr>
+          <p:cNvPr id="37" name="Straight Connector 36">
+            <a:extLst>
+              <a:ext uri="{FF2B5EF4-FFF2-40B4-BE49-F238E27FC236}">
+                <a16:creationId xmlns:a16="http://schemas.microsoft.com/office/drawing/2014/main" id="{5270AF8B-A7AA-2B44-21F5-8C100DF69688}"/>
+              </a:ext>
+            </a:extLst>
+          </p:cNvPr>
+          <p:cNvCxnSpPr/>
+          <p:nvPr/>
+        </p:nvCxnSpPr>
+        <p:spPr>
+          <a:xfrm flipH="1">
+            <a:off x="4939986" y="1663998"/>
+            <a:ext cx="66503" cy="3857105"/>
+          </a:xfrm>
+          <a:prstGeom prst="line">
+            <a:avLst/>
+          </a:prstGeom>
+        </p:spPr>
+        <p:style>
+          <a:lnRef idx="3">
+            <a:schemeClr val="accent1"/>
+          </a:lnRef>
+          <a:fillRef idx="0">
+            <a:schemeClr val="accent1"/>
+          </a:fillRef>
+          <a:effectRef idx="2">
+            <a:schemeClr val="accent1"/>
+          </a:effectRef>
+          <a:fontRef idx="minor">
+            <a:schemeClr val="tx1"/>
+          </a:fontRef>
+        </p:style>
+      </p:cxnSp>
+      <p:sp>
+        <p:nvSpPr>
+          <p:cNvPr id="39" name="TextBox 38">
+            <a:extLst>
+              <a:ext uri="{FF2B5EF4-FFF2-40B4-BE49-F238E27FC236}">
+                <a16:creationId xmlns:a16="http://schemas.microsoft.com/office/drawing/2014/main" id="{0B195326-CACE-F30F-6A1F-5C72C510581B}"/>
+              </a:ext>
+            </a:extLst>
+          </p:cNvPr>
+          <p:cNvSpPr txBox="1"/>
+          <p:nvPr/>
+        </p:nvSpPr>
+        <p:spPr>
+          <a:xfrm>
+            <a:off x="2254026" y="1617599"/>
+            <a:ext cx="2557110" cy="276999"/>
+          </a:xfrm>
+          <a:prstGeom prst="rect">
+            <a:avLst/>
+          </a:prstGeom>
+          <a:noFill/>
+        </p:spPr>
+        <p:txBody>
+          <a:bodyPr wrap="none" rtlCol="0">
+            <a:spAutoFit/>
+          </a:bodyPr>
+          <a:lstStyle/>
+          <a:p>
+            <a:pPr algn="ctr"/>
+            <a:r>
+              <a:rPr lang="en-US" sz="1200" dirty="0"/>
+              <a:t>Payer shares </a:t>
+            </a:r>
+            <a:r>
+              <a:rPr lang="en-US" sz="1200" b="1" dirty="0"/>
+              <a:t>ATR Group</a:t>
+            </a:r>
+            <a:r>
+              <a:rPr lang="en-US" sz="1200" dirty="0"/>
+              <a:t> with Provider</a:t>
+            </a:r>
+          </a:p>
+        </p:txBody>
+      </p:sp>
+      <p:sp>
+        <p:nvSpPr>
+          <p:cNvPr id="41" name="Arrow: Left-Right 40">
+            <a:extLst>
+              <a:ext uri="{FF2B5EF4-FFF2-40B4-BE49-F238E27FC236}">
+                <a16:creationId xmlns:a16="http://schemas.microsoft.com/office/drawing/2014/main" id="{F5D0FF30-0E5A-AB1C-37E4-DA278EDD4720}"/>
+              </a:ext>
+            </a:extLst>
+          </p:cNvPr>
+          <p:cNvSpPr/>
+          <p:nvPr/>
+        </p:nvSpPr>
+        <p:spPr>
+          <a:xfrm>
+            <a:off x="1981793" y="2602824"/>
+            <a:ext cx="2958192" cy="110833"/>
+          </a:xfrm>
+          <a:prstGeom prst="leftRightArrow">
+            <a:avLst/>
+          </a:prstGeom>
+        </p:spPr>
+        <p:style>
+          <a:lnRef idx="2">
+            <a:schemeClr val="accent1">
+              <a:shade val="15000"/>
+            </a:schemeClr>
+          </a:lnRef>
+          <a:fillRef idx="1">
+            <a:schemeClr val="accent1"/>
+          </a:fillRef>
+          <a:effectRef idx="0">
+            <a:schemeClr val="accent1"/>
+          </a:effectRef>
+          <a:fontRef idx="minor">
+            <a:schemeClr val="lt1"/>
+          </a:fontRef>
+        </p:style>
+        <p:txBody>
+          <a:bodyPr rtlCol="0" anchor="ctr"/>
+          <a:lstStyle/>
+          <a:p>
+            <a:pPr algn="ctr"/>
+            <a:endParaRPr lang="en-US" sz="2400"/>
+          </a:p>
+        </p:txBody>
+      </p:sp>
+      <p:sp>
+        <p:nvSpPr>
+          <p:cNvPr id="43" name="TextBox 42">
+            <a:extLst>
+              <a:ext uri="{FF2B5EF4-FFF2-40B4-BE49-F238E27FC236}">
+                <a16:creationId xmlns:a16="http://schemas.microsoft.com/office/drawing/2014/main" id="{71F14DEB-7F77-C1A5-A553-D0993841936D}"/>
+              </a:ext>
+            </a:extLst>
+          </p:cNvPr>
+          <p:cNvSpPr txBox="1"/>
+          <p:nvPr/>
+        </p:nvSpPr>
+        <p:spPr>
+          <a:xfrm>
+            <a:off x="2147170" y="2301470"/>
+            <a:ext cx="2668231" cy="276999"/>
+          </a:xfrm>
+          <a:prstGeom prst="rect">
+            <a:avLst/>
+          </a:prstGeom>
+          <a:noFill/>
+        </p:spPr>
+        <p:txBody>
+          <a:bodyPr wrap="none" rtlCol="0">
+            <a:spAutoFit/>
+          </a:bodyPr>
+          <a:lstStyle/>
+          <a:p>
+            <a:pPr algn="ctr"/>
+            <a:r>
+              <a:rPr lang="en-US" sz="1200" dirty="0"/>
+              <a:t>Provider shares </a:t>
+            </a:r>
+            <a:r>
+              <a:rPr lang="en-US" sz="1200" b="1" dirty="0"/>
+              <a:t>Clinical Data</a:t>
+            </a:r>
+            <a:r>
+              <a:rPr lang="en-US" sz="1200" dirty="0"/>
+              <a:t> with Payer</a:t>
+            </a:r>
+          </a:p>
+        </p:txBody>
+      </p:sp>
+      <p:sp>
+        <p:nvSpPr>
+          <p:cNvPr id="45" name="TextBox 44">
+            <a:extLst>
+              <a:ext uri="{FF2B5EF4-FFF2-40B4-BE49-F238E27FC236}">
+                <a16:creationId xmlns:a16="http://schemas.microsoft.com/office/drawing/2014/main" id="{4B159B6A-DE55-87D1-0C53-249F1178B50C}"/>
+              </a:ext>
+            </a:extLst>
+          </p:cNvPr>
+          <p:cNvSpPr txBox="1"/>
+          <p:nvPr/>
+        </p:nvSpPr>
+        <p:spPr>
+          <a:xfrm>
+            <a:off x="6549109" y="2653330"/>
+            <a:ext cx="2677384" cy="461665"/>
+          </a:xfrm>
+          <a:prstGeom prst="rect">
+            <a:avLst/>
+          </a:prstGeom>
+          <a:noFill/>
+        </p:spPr>
+        <p:txBody>
+          <a:bodyPr wrap="square" rtlCol="0">
+            <a:spAutoFit/>
+          </a:bodyPr>
+          <a:lstStyle/>
+          <a:p>
+            <a:pPr algn="ctr"/>
+            <a:r>
+              <a:rPr lang="en-US" sz="1200" dirty="0"/>
+              <a:t>Payer shares </a:t>
+            </a:r>
+            <a:r>
+              <a:rPr lang="en-US" sz="1200" b="1" dirty="0"/>
+              <a:t>Clinical and Claims Data</a:t>
+            </a:r>
+            <a:r>
+              <a:rPr lang="en-US" sz="1200" dirty="0"/>
+              <a:t> with Reporting System</a:t>
+            </a:r>
+          </a:p>
+        </p:txBody>
+      </p:sp>
+      <p:pic>
+        <p:nvPicPr>
+          <p:cNvPr id="49" name="Picture 10" descr="Engine Gears Icon SVG Vector &amp; PNG Free Download | UXWing">
+            <a:extLst>
+              <a:ext uri="{FF2B5EF4-FFF2-40B4-BE49-F238E27FC236}">
+                <a16:creationId xmlns:a16="http://schemas.microsoft.com/office/drawing/2014/main" id="{CFA03D03-1CE9-0256-BCE9-99D73D2D43F6}"/>
+              </a:ext>
+            </a:extLst>
+          </p:cNvPr>
+          <p:cNvPicPr>
+            <a:picLocks noChangeAspect="1" noChangeArrowheads="1"/>
+          </p:cNvPicPr>
+          <p:nvPr/>
+        </p:nvPicPr>
+        <p:blipFill>
+          <a:blip r:embed="rId5">
+            <a:extLst>
+              <a:ext uri="{28A0092B-C50C-407E-A947-70E740481C1C}">
+                <a14:useLocalDpi xmlns:a14="http://schemas.microsoft.com/office/drawing/2010/main" val="0"/>
+              </a:ext>
+            </a:extLst>
+          </a:blip>
+          <a:srcRect/>
+          <a:stretch>
+            <a:fillRect/>
+          </a:stretch>
+        </p:blipFill>
+        <p:spPr bwMode="auto">
+          <a:xfrm>
+            <a:off x="10163328" y="3422781"/>
+            <a:ext cx="771283" cy="873632"/>
+          </a:xfrm>
+          <a:prstGeom prst="rect">
+            <a:avLst/>
+          </a:prstGeom>
+          <a:noFill/>
+          <a:extLst>
+            <a:ext uri="{909E8E84-426E-40DD-AFC4-6F175D3DCCD1}">
+              <a14:hiddenFill xmlns:a14="http://schemas.microsoft.com/office/drawing/2010/main">
+                <a:solidFill>
+                  <a:srgbClr val="FFFFFF"/>
+                </a:solidFill>
+              </a14:hiddenFill>
+            </a:ext>
+          </a:extLst>
+        </p:spPr>
+      </p:pic>
+      <p:pic>
+        <p:nvPicPr>
+          <p:cNvPr id="51" name="Picture 18" descr="Database Icons - Free SVG &amp; PNG Database Images - Noun Project">
+            <a:extLst>
+              <a:ext uri="{FF2B5EF4-FFF2-40B4-BE49-F238E27FC236}">
+                <a16:creationId xmlns:a16="http://schemas.microsoft.com/office/drawing/2014/main" id="{F0555409-43DC-15D6-62EB-0D191EA29FA6}"/>
+              </a:ext>
+            </a:extLst>
+          </p:cNvPr>
+          <p:cNvPicPr>
+            <a:picLocks noChangeAspect="1" noChangeArrowheads="1"/>
+          </p:cNvPicPr>
+          <p:nvPr/>
+        </p:nvPicPr>
+        <p:blipFill>
+          <a:blip r:embed="rId6">
+            <a:extLst>
+              <a:ext uri="{28A0092B-C50C-407E-A947-70E740481C1C}">
+                <a14:useLocalDpi xmlns:a14="http://schemas.microsoft.com/office/drawing/2010/main" val="0"/>
+              </a:ext>
+            </a:extLst>
+          </a:blip>
+          <a:srcRect/>
+          <a:stretch>
+            <a:fillRect/>
+          </a:stretch>
+        </p:blipFill>
+        <p:spPr bwMode="auto">
+          <a:xfrm>
+            <a:off x="9777685" y="3679435"/>
+            <a:ext cx="771283" cy="771283"/>
+          </a:xfrm>
+          <a:prstGeom prst="rect">
+            <a:avLst/>
+          </a:prstGeom>
+          <a:noFill/>
+          <a:extLst>
+            <a:ext uri="{909E8E84-426E-40DD-AFC4-6F175D3DCCD1}">
+              <a14:hiddenFill xmlns:a14="http://schemas.microsoft.com/office/drawing/2010/main">
+                <a:solidFill>
+                  <a:srgbClr val="FFFFFF"/>
+                </a:solidFill>
+              </a14:hiddenFill>
+            </a:ext>
+          </a:extLst>
+        </p:spPr>
+      </p:pic>
+      <p:sp>
+        <p:nvSpPr>
+          <p:cNvPr id="53" name="TextBox 52">
+            <a:extLst>
+              <a:ext uri="{FF2B5EF4-FFF2-40B4-BE49-F238E27FC236}">
+                <a16:creationId xmlns:a16="http://schemas.microsoft.com/office/drawing/2014/main" id="{3BA42616-0865-87AA-ACFC-101594780592}"/>
+              </a:ext>
+            </a:extLst>
+          </p:cNvPr>
+          <p:cNvSpPr txBox="1"/>
+          <p:nvPr/>
+        </p:nvSpPr>
+        <p:spPr>
+          <a:xfrm>
+            <a:off x="9512869" y="2487112"/>
+            <a:ext cx="1300915" cy="523220"/>
+          </a:xfrm>
+          <a:prstGeom prst="rect">
+            <a:avLst/>
+          </a:prstGeom>
+          <a:noFill/>
+        </p:spPr>
+        <p:txBody>
+          <a:bodyPr wrap="square" rtlCol="0">
+            <a:spAutoFit/>
+          </a:bodyPr>
+          <a:lstStyle/>
+          <a:p>
+            <a:pPr algn="ctr"/>
+            <a:r>
+              <a:rPr lang="en-US" sz="1400" b="1" dirty="0"/>
+              <a:t>Reporting System</a:t>
+            </a:r>
+          </a:p>
+        </p:txBody>
+      </p:sp>
+      <p:sp>
+        <p:nvSpPr>
+          <p:cNvPr id="55" name="TextBox 54">
+            <a:extLst>
+              <a:ext uri="{FF2B5EF4-FFF2-40B4-BE49-F238E27FC236}">
+                <a16:creationId xmlns:a16="http://schemas.microsoft.com/office/drawing/2014/main" id="{482656D1-0D17-BF1A-2B47-E4CB677A7D4E}"/>
+              </a:ext>
+            </a:extLst>
+          </p:cNvPr>
+          <p:cNvSpPr txBox="1"/>
+          <p:nvPr/>
+        </p:nvSpPr>
+        <p:spPr>
+          <a:xfrm>
+            <a:off x="6544349" y="3234670"/>
+            <a:ext cx="2478883" cy="646331"/>
+          </a:xfrm>
+          <a:prstGeom prst="rect">
+            <a:avLst/>
+          </a:prstGeom>
+          <a:noFill/>
+        </p:spPr>
+        <p:txBody>
+          <a:bodyPr wrap="square" rtlCol="0">
+            <a:spAutoFit/>
+          </a:bodyPr>
+          <a:lstStyle/>
+          <a:p>
+            <a:pPr algn="ctr"/>
+            <a:r>
+              <a:rPr lang="en-US" sz="1200" dirty="0"/>
+              <a:t>Reporting system shares </a:t>
+            </a:r>
+            <a:r>
+              <a:rPr lang="en-US" sz="1200" b="1" dirty="0"/>
+              <a:t>Patient- and Population-level Results</a:t>
+            </a:r>
+            <a:r>
+              <a:rPr lang="en-US" sz="1200" dirty="0"/>
+              <a:t> with Payer</a:t>
+            </a:r>
+          </a:p>
+        </p:txBody>
+      </p:sp>
+      <p:sp>
+        <p:nvSpPr>
+          <p:cNvPr id="57" name="TextBox 56">
+            <a:extLst>
+              <a:ext uri="{FF2B5EF4-FFF2-40B4-BE49-F238E27FC236}">
+                <a16:creationId xmlns:a16="http://schemas.microsoft.com/office/drawing/2014/main" id="{ACB335C3-8600-EDF8-4372-E5FF92F07C4B}"/>
+              </a:ext>
+            </a:extLst>
+          </p:cNvPr>
+          <p:cNvSpPr txBox="1"/>
+          <p:nvPr/>
+        </p:nvSpPr>
+        <p:spPr>
+          <a:xfrm>
+            <a:off x="1906280" y="4015890"/>
+            <a:ext cx="2930109" cy="461665"/>
+          </a:xfrm>
+          <a:prstGeom prst="rect">
+            <a:avLst/>
+          </a:prstGeom>
+          <a:noFill/>
+        </p:spPr>
+        <p:txBody>
+          <a:bodyPr wrap="square" rtlCol="0">
+            <a:spAutoFit/>
+          </a:bodyPr>
+          <a:lstStyle/>
+          <a:p>
+            <a:pPr algn="ctr"/>
+            <a:r>
+              <a:rPr lang="en-US" sz="1200" dirty="0"/>
+              <a:t>Payer shares </a:t>
+            </a:r>
+            <a:r>
+              <a:rPr lang="en-US" sz="1200" b="1" dirty="0"/>
+              <a:t>Patient-level Results</a:t>
+            </a:r>
+            <a:r>
+              <a:rPr lang="en-US" sz="1200" dirty="0"/>
+              <a:t> with Provider</a:t>
+            </a:r>
+          </a:p>
+        </p:txBody>
+      </p:sp>
+      <p:cxnSp>
+        <p:nvCxnSpPr>
+          <p:cNvPr id="58" name="Straight Connector 57">
+            <a:extLst>
+              <a:ext uri="{FF2B5EF4-FFF2-40B4-BE49-F238E27FC236}">
+                <a16:creationId xmlns:a16="http://schemas.microsoft.com/office/drawing/2014/main" id="{22ED3C93-96B5-1F3D-5294-FD0F79B7DBEA}"/>
+              </a:ext>
+            </a:extLst>
+          </p:cNvPr>
+          <p:cNvCxnSpPr/>
+          <p:nvPr/>
+        </p:nvCxnSpPr>
+        <p:spPr>
+          <a:xfrm flipH="1">
+            <a:off x="6352007" y="1644673"/>
+            <a:ext cx="66503" cy="3857105"/>
+          </a:xfrm>
+          <a:prstGeom prst="line">
+            <a:avLst/>
+          </a:prstGeom>
+        </p:spPr>
+        <p:style>
+          <a:lnRef idx="3">
+            <a:schemeClr val="accent1"/>
+          </a:lnRef>
+          <a:fillRef idx="0">
+            <a:schemeClr val="accent1"/>
+          </a:fillRef>
+          <a:effectRef idx="2">
+            <a:schemeClr val="accent1"/>
+          </a:effectRef>
+          <a:fontRef idx="minor">
+            <a:schemeClr val="tx1"/>
+          </a:fontRef>
+        </p:style>
+      </p:cxnSp>
+      <p:cxnSp>
+        <p:nvCxnSpPr>
+          <p:cNvPr id="59" name="Straight Connector 58">
+            <a:extLst>
+              <a:ext uri="{FF2B5EF4-FFF2-40B4-BE49-F238E27FC236}">
+                <a16:creationId xmlns:a16="http://schemas.microsoft.com/office/drawing/2014/main" id="{0EE07115-FE96-1131-BECB-11A00650A615}"/>
+              </a:ext>
+            </a:extLst>
+          </p:cNvPr>
+          <p:cNvCxnSpPr/>
+          <p:nvPr/>
+        </p:nvCxnSpPr>
+        <p:spPr>
+          <a:xfrm flipH="1">
+            <a:off x="9368169" y="1632513"/>
+            <a:ext cx="66503" cy="3857105"/>
+          </a:xfrm>
+          <a:prstGeom prst="line">
+            <a:avLst/>
+          </a:prstGeom>
+        </p:spPr>
+        <p:style>
+          <a:lnRef idx="3">
+            <a:schemeClr val="accent1"/>
+          </a:lnRef>
+          <a:fillRef idx="0">
+            <a:schemeClr val="accent1"/>
+          </a:fillRef>
+          <a:effectRef idx="2">
+            <a:schemeClr val="accent1"/>
+          </a:effectRef>
+          <a:fontRef idx="minor">
+            <a:schemeClr val="tx1"/>
+          </a:fontRef>
+        </p:style>
+      </p:cxnSp>
+      <p:sp>
+        <p:nvSpPr>
+          <p:cNvPr id="61" name="Arrow: Left-Right 60">
+            <a:extLst>
+              <a:ext uri="{FF2B5EF4-FFF2-40B4-BE49-F238E27FC236}">
+                <a16:creationId xmlns:a16="http://schemas.microsoft.com/office/drawing/2014/main" id="{C5ABC705-8F7F-7612-455D-FC4D27CAFEF7}"/>
+              </a:ext>
+            </a:extLst>
+          </p:cNvPr>
+          <p:cNvSpPr/>
+          <p:nvPr/>
+        </p:nvSpPr>
+        <p:spPr>
+          <a:xfrm>
+            <a:off x="2002188" y="1947802"/>
+            <a:ext cx="2958192" cy="110833"/>
+          </a:xfrm>
+          <a:prstGeom prst="leftRightArrow">
+            <a:avLst/>
+          </a:prstGeom>
+        </p:spPr>
+        <p:style>
+          <a:lnRef idx="2">
+            <a:schemeClr val="accent1">
+              <a:shade val="15000"/>
+            </a:schemeClr>
+          </a:lnRef>
+          <a:fillRef idx="1">
+            <a:schemeClr val="accent1"/>
+          </a:fillRef>
+          <a:effectRef idx="0">
+            <a:schemeClr val="accent1"/>
+          </a:effectRef>
+          <a:fontRef idx="minor">
+            <a:schemeClr val="lt1"/>
+          </a:fontRef>
+        </p:style>
+        <p:txBody>
+          <a:bodyPr rtlCol="0" anchor="ctr"/>
+          <a:lstStyle/>
+          <a:p>
+            <a:pPr algn="ctr"/>
+            <a:endParaRPr lang="en-US" sz="2400"/>
+          </a:p>
+        </p:txBody>
+      </p:sp>
+      <p:sp>
+        <p:nvSpPr>
+          <p:cNvPr id="63" name="Arrow: Left-Right 62">
+            <a:extLst>
+              <a:ext uri="{FF2B5EF4-FFF2-40B4-BE49-F238E27FC236}">
+                <a16:creationId xmlns:a16="http://schemas.microsoft.com/office/drawing/2014/main" id="{F8A9A1EA-BB1A-A1F9-B424-251B63E28AD0}"/>
+              </a:ext>
+            </a:extLst>
+          </p:cNvPr>
+          <p:cNvSpPr/>
+          <p:nvPr/>
+        </p:nvSpPr>
+        <p:spPr>
+          <a:xfrm>
+            <a:off x="6414243" y="3131229"/>
+            <a:ext cx="2958192" cy="110833"/>
+          </a:xfrm>
+          <a:prstGeom prst="leftRightArrow">
+            <a:avLst/>
+          </a:prstGeom>
+        </p:spPr>
+        <p:style>
+          <a:lnRef idx="2">
+            <a:schemeClr val="accent1">
+              <a:shade val="15000"/>
+            </a:schemeClr>
+          </a:lnRef>
+          <a:fillRef idx="1">
+            <a:schemeClr val="accent1"/>
+          </a:fillRef>
+          <a:effectRef idx="0">
+            <a:schemeClr val="accent1"/>
+          </a:effectRef>
+          <a:fontRef idx="minor">
+            <a:schemeClr val="lt1"/>
+          </a:fontRef>
+        </p:style>
+        <p:txBody>
+          <a:bodyPr rtlCol="0" anchor="ctr"/>
+          <a:lstStyle/>
+          <a:p>
+            <a:pPr algn="ctr"/>
+            <a:endParaRPr lang="en-US" sz="2400"/>
+          </a:p>
+        </p:txBody>
+      </p:sp>
+      <p:sp>
+        <p:nvSpPr>
+          <p:cNvPr id="65" name="Arrow: Left-Right 64">
+            <a:extLst>
+              <a:ext uri="{FF2B5EF4-FFF2-40B4-BE49-F238E27FC236}">
+                <a16:creationId xmlns:a16="http://schemas.microsoft.com/office/drawing/2014/main" id="{E9A67F5F-CDE6-95BB-D26F-8C22334E398E}"/>
+              </a:ext>
+            </a:extLst>
+          </p:cNvPr>
+          <p:cNvSpPr/>
+          <p:nvPr/>
+        </p:nvSpPr>
+        <p:spPr>
+          <a:xfrm>
+            <a:off x="6408705" y="3887786"/>
+            <a:ext cx="2958192" cy="110833"/>
+          </a:xfrm>
+          <a:prstGeom prst="leftRightArrow">
+            <a:avLst/>
+          </a:prstGeom>
+        </p:spPr>
+        <p:style>
+          <a:lnRef idx="2">
+            <a:schemeClr val="accent1">
+              <a:shade val="15000"/>
+            </a:schemeClr>
+          </a:lnRef>
+          <a:fillRef idx="1">
+            <a:schemeClr val="accent1"/>
+          </a:fillRef>
+          <a:effectRef idx="0">
+            <a:schemeClr val="accent1"/>
+          </a:effectRef>
+          <a:fontRef idx="minor">
+            <a:schemeClr val="lt1"/>
+          </a:fontRef>
+        </p:style>
+        <p:txBody>
+          <a:bodyPr rtlCol="0" anchor="ctr"/>
+          <a:lstStyle/>
+          <a:p>
+            <a:pPr algn="ctr"/>
+            <a:endParaRPr lang="en-US" sz="2400"/>
+          </a:p>
+        </p:txBody>
+      </p:sp>
+      <p:sp>
+        <p:nvSpPr>
+          <p:cNvPr id="67" name="Arrow: Left-Right 66">
+            <a:extLst>
+              <a:ext uri="{FF2B5EF4-FFF2-40B4-BE49-F238E27FC236}">
+                <a16:creationId xmlns:a16="http://schemas.microsoft.com/office/drawing/2014/main" id="{8AC6B301-BEDE-0F76-2BB6-C5A03D874C76}"/>
+              </a:ext>
+            </a:extLst>
+          </p:cNvPr>
+          <p:cNvSpPr/>
+          <p:nvPr/>
+        </p:nvSpPr>
+        <p:spPr>
+          <a:xfrm>
+            <a:off x="1956396" y="4441789"/>
+            <a:ext cx="2958192" cy="110833"/>
+          </a:xfrm>
+          <a:prstGeom prst="leftRightArrow">
+            <a:avLst/>
+          </a:prstGeom>
+        </p:spPr>
+        <p:style>
+          <a:lnRef idx="2">
+            <a:schemeClr val="accent1">
+              <a:shade val="15000"/>
+            </a:schemeClr>
+          </a:lnRef>
+          <a:fillRef idx="1">
+            <a:schemeClr val="accent1"/>
+          </a:fillRef>
+          <a:effectRef idx="0">
+            <a:schemeClr val="accent1"/>
+          </a:effectRef>
+          <a:fontRef idx="minor">
+            <a:schemeClr val="lt1"/>
+          </a:fontRef>
+        </p:style>
+        <p:txBody>
+          <a:bodyPr rtlCol="0" anchor="ctr"/>
+          <a:lstStyle/>
+          <a:p>
+            <a:pPr algn="ctr"/>
+            <a:endParaRPr lang="en-US" sz="2400"/>
+          </a:p>
+        </p:txBody>
+      </p:sp>
+      <p:sp>
+        <p:nvSpPr>
+          <p:cNvPr id="68" name="Oval 67">
+            <a:extLst>
+              <a:ext uri="{FF2B5EF4-FFF2-40B4-BE49-F238E27FC236}">
+                <a16:creationId xmlns:a16="http://schemas.microsoft.com/office/drawing/2014/main" id="{4D3033DE-D2AA-E5BD-C6AE-8CDB376B083A}"/>
+              </a:ext>
+            </a:extLst>
+          </p:cNvPr>
+          <p:cNvSpPr/>
+          <p:nvPr/>
+        </p:nvSpPr>
+        <p:spPr>
+          <a:xfrm>
+            <a:off x="1839114" y="1644673"/>
+            <a:ext cx="233932" cy="225065"/>
+          </a:xfrm>
+          <a:prstGeom prst="ellipse">
+            <a:avLst/>
+          </a:prstGeom>
+        </p:spPr>
+        <p:style>
+          <a:lnRef idx="2">
+            <a:schemeClr val="accent1">
+              <a:shade val="15000"/>
+            </a:schemeClr>
+          </a:lnRef>
+          <a:fillRef idx="1">
+            <a:schemeClr val="accent1"/>
+          </a:fillRef>
+          <a:effectRef idx="0">
+            <a:schemeClr val="accent1"/>
+          </a:effectRef>
+          <a:fontRef idx="minor">
+            <a:schemeClr val="lt1"/>
+          </a:fontRef>
+        </p:style>
+        <p:txBody>
+          <a:bodyPr rtlCol="0" anchor="ctr"/>
+          <a:lstStyle/>
+          <a:p>
+            <a:pPr algn="ctr"/>
+            <a:r>
+              <a:rPr lang="en-US" sz="1333" dirty="0"/>
+              <a:t>1</a:t>
+            </a:r>
+          </a:p>
+        </p:txBody>
+      </p:sp>
+      <p:sp>
+        <p:nvSpPr>
+          <p:cNvPr id="70" name="Oval 69">
+            <a:extLst>
+              <a:ext uri="{FF2B5EF4-FFF2-40B4-BE49-F238E27FC236}">
+                <a16:creationId xmlns:a16="http://schemas.microsoft.com/office/drawing/2014/main" id="{D0CE571F-C81E-3999-0DC1-A80B11C27D9A}"/>
+              </a:ext>
+            </a:extLst>
+          </p:cNvPr>
+          <p:cNvSpPr/>
+          <p:nvPr/>
+        </p:nvSpPr>
+        <p:spPr>
+          <a:xfrm>
+            <a:off x="1809682" y="2312577"/>
+            <a:ext cx="233932" cy="225065"/>
+          </a:xfrm>
+          <a:prstGeom prst="ellipse">
+            <a:avLst/>
+          </a:prstGeom>
+        </p:spPr>
+        <p:style>
+          <a:lnRef idx="2">
+            <a:schemeClr val="accent1">
+              <a:shade val="15000"/>
+            </a:schemeClr>
+          </a:lnRef>
+          <a:fillRef idx="1">
+            <a:schemeClr val="accent1"/>
+          </a:fillRef>
+          <a:effectRef idx="0">
+            <a:schemeClr val="accent1"/>
+          </a:effectRef>
+          <a:fontRef idx="minor">
+            <a:schemeClr val="lt1"/>
+          </a:fontRef>
+        </p:style>
+        <p:txBody>
+          <a:bodyPr rtlCol="0" anchor="ctr"/>
+          <a:lstStyle/>
+          <a:p>
+            <a:pPr algn="ctr"/>
+            <a:r>
+              <a:rPr lang="en-US" sz="1333" dirty="0"/>
+              <a:t>2</a:t>
+            </a:r>
+          </a:p>
+        </p:txBody>
+      </p:sp>
+      <p:sp>
+        <p:nvSpPr>
+          <p:cNvPr id="72" name="Oval 71">
+            <a:extLst>
+              <a:ext uri="{FF2B5EF4-FFF2-40B4-BE49-F238E27FC236}">
+                <a16:creationId xmlns:a16="http://schemas.microsoft.com/office/drawing/2014/main" id="{4F47A24D-9EAC-F799-E45C-B2D0609B2AE7}"/>
+              </a:ext>
+            </a:extLst>
+          </p:cNvPr>
+          <p:cNvSpPr/>
+          <p:nvPr/>
+        </p:nvSpPr>
+        <p:spPr>
+          <a:xfrm>
+            <a:off x="6284557" y="2816045"/>
+            <a:ext cx="233932" cy="225065"/>
+          </a:xfrm>
+          <a:prstGeom prst="ellipse">
+            <a:avLst/>
+          </a:prstGeom>
+        </p:spPr>
+        <p:style>
+          <a:lnRef idx="2">
+            <a:schemeClr val="accent1">
+              <a:shade val="15000"/>
+            </a:schemeClr>
+          </a:lnRef>
+          <a:fillRef idx="1">
+            <a:schemeClr val="accent1"/>
+          </a:fillRef>
+          <a:effectRef idx="0">
+            <a:schemeClr val="accent1"/>
+          </a:effectRef>
+          <a:fontRef idx="minor">
+            <a:schemeClr val="lt1"/>
+          </a:fontRef>
+        </p:style>
+        <p:txBody>
+          <a:bodyPr rtlCol="0" anchor="ctr"/>
+          <a:lstStyle/>
+          <a:p>
+            <a:pPr algn="ctr"/>
+            <a:r>
+              <a:rPr lang="en-US" sz="1333" dirty="0"/>
+              <a:t>3</a:t>
+            </a:r>
+          </a:p>
+        </p:txBody>
+      </p:sp>
+      <p:sp>
+        <p:nvSpPr>
+          <p:cNvPr id="74" name="Oval 73">
+            <a:extLst>
+              <a:ext uri="{FF2B5EF4-FFF2-40B4-BE49-F238E27FC236}">
+                <a16:creationId xmlns:a16="http://schemas.microsoft.com/office/drawing/2014/main" id="{9DEE05D3-12F0-C969-9360-450530121D3E}"/>
+              </a:ext>
+            </a:extLst>
+          </p:cNvPr>
+          <p:cNvSpPr/>
+          <p:nvPr/>
+        </p:nvSpPr>
+        <p:spPr>
+          <a:xfrm>
+            <a:off x="6284557" y="3561065"/>
+            <a:ext cx="233932" cy="225065"/>
+          </a:xfrm>
+          <a:prstGeom prst="ellipse">
+            <a:avLst/>
+          </a:prstGeom>
+        </p:spPr>
+        <p:style>
+          <a:lnRef idx="2">
+            <a:schemeClr val="accent1">
+              <a:shade val="15000"/>
+            </a:schemeClr>
+          </a:lnRef>
+          <a:fillRef idx="1">
+            <a:schemeClr val="accent1"/>
+          </a:fillRef>
+          <a:effectRef idx="0">
+            <a:schemeClr val="accent1"/>
+          </a:effectRef>
+          <a:fontRef idx="minor">
+            <a:schemeClr val="lt1"/>
+          </a:fontRef>
+        </p:style>
+        <p:txBody>
+          <a:bodyPr rtlCol="0" anchor="ctr"/>
+          <a:lstStyle/>
+          <a:p>
+            <a:pPr algn="ctr"/>
+            <a:r>
+              <a:rPr lang="en-US" sz="1333" dirty="0"/>
+              <a:t>4</a:t>
+            </a:r>
+          </a:p>
+        </p:txBody>
+      </p:sp>
+      <p:sp>
+        <p:nvSpPr>
+          <p:cNvPr id="76" name="Oval 75">
+            <a:extLst>
+              <a:ext uri="{FF2B5EF4-FFF2-40B4-BE49-F238E27FC236}">
+                <a16:creationId xmlns:a16="http://schemas.microsoft.com/office/drawing/2014/main" id="{D5FE36E9-19C8-F4BB-DE7E-CCCA64AEE750}"/>
+              </a:ext>
+            </a:extLst>
+          </p:cNvPr>
+          <p:cNvSpPr/>
+          <p:nvPr/>
+        </p:nvSpPr>
+        <p:spPr>
+          <a:xfrm>
+            <a:off x="1797657" y="4119778"/>
+            <a:ext cx="233932" cy="225065"/>
+          </a:xfrm>
+          <a:prstGeom prst="ellipse">
+            <a:avLst/>
+          </a:prstGeom>
+        </p:spPr>
+        <p:style>
+          <a:lnRef idx="2">
+            <a:schemeClr val="accent1">
+              <a:shade val="15000"/>
+            </a:schemeClr>
+          </a:lnRef>
+          <a:fillRef idx="1">
+            <a:schemeClr val="accent1"/>
+          </a:fillRef>
+          <a:effectRef idx="0">
+            <a:schemeClr val="accent1"/>
+          </a:effectRef>
+          <a:fontRef idx="minor">
+            <a:schemeClr val="lt1"/>
+          </a:fontRef>
+        </p:style>
+        <p:txBody>
+          <a:bodyPr rtlCol="0" anchor="ctr"/>
+          <a:lstStyle/>
+          <a:p>
+            <a:pPr algn="ctr"/>
+            <a:r>
+              <a:rPr lang="en-US" sz="1333" dirty="0"/>
+              <a:t>5</a:t>
+            </a:r>
+          </a:p>
+        </p:txBody>
+      </p:sp>
+    </p:spTree>
+    <p:extLst>
+      <p:ext uri="{BB962C8B-B14F-4D97-AF65-F5344CB8AC3E}">
+        <p14:creationId xmlns:p14="http://schemas.microsoft.com/office/powerpoint/2010/main" val="2787169849"/>
       </p:ext>
     </p:extLst>
   </p:cSld>

</xml_diff>